<commit_message>
modified payment success screen with a gif
</commit_message>
<xml_diff>
--- a/JR upd UI.pptx
+++ b/JR upd UI.pptx
@@ -4,17 +4,20 @@
   <p:sldMasterIdLst>
     <p:sldMasterId id="2147483648" r:id="rId1"/>
   </p:sldMasterIdLst>
+  <p:notesMasterIdLst>
+    <p:notesMasterId r:id="rId10"/>
+  </p:notesMasterIdLst>
   <p:sldIdLst>
-    <p:sldId id="256" r:id="rId7"/>
-    <p:sldId id="257" r:id="rId8"/>
-    <p:sldId id="258" r:id="rId9"/>
-    <p:sldId id="260" r:id="rId11"/>
-    <p:sldId id="261" r:id="rId12"/>
-    <p:sldId id="262" r:id="rId13"/>
-    <p:sldId id="263" r:id="rId14"/>
-    <p:sldId id="264" r:id="rId15"/>
+    <p:sldId id="256" r:id="rId2"/>
+    <p:sldId id="257" r:id="rId3"/>
+    <p:sldId id="258" r:id="rId4"/>
+    <p:sldId id="260" r:id="rId5"/>
+    <p:sldId id="261" r:id="rId6"/>
+    <p:sldId id="262" r:id="rId7"/>
+    <p:sldId id="263" r:id="rId8"/>
+    <p:sldId id="264" r:id="rId9"/>
   </p:sldIdLst>
-  <p:sldSz cx="12191695" cy="6858000" type="screen4x3"/>
+  <p:sldSz cx="12192000" cy="6858000"/>
   <p:notesSz cx="6858000" cy="9144000"/>
   <p:defaultTextStyle>
     <a:defPPr>
@@ -111,7 +114,1089 @@
       </a:defRPr>
     </a:lvl9pPr>
   </p:defaultTextStyle>
+  <p:extLst>
+    <p:ext uri="{EFAFB233-063F-42B5-8137-9DF3F51BA10A}">
+      <p15:sldGuideLst xmlns:p15="http://schemas.microsoft.com/office/powerpoint/2012/main">
+        <p15:guide id="1" orient="horz" pos="2160">
+          <p15:clr>
+            <a:srgbClr val="A4A3A4"/>
+          </p15:clr>
+        </p15:guide>
+        <p15:guide id="2" pos="2880">
+          <p15:clr>
+            <a:srgbClr val="A4A3A4"/>
+          </p15:clr>
+        </p15:guide>
+      </p15:sldGuideLst>
+    </p:ext>
+  </p:extLst>
 </p:presentation>
+</file>
+
+<file path=ppt/notesMasters/notesMaster1.xml><?xml version="1.0" encoding="utf-8"?>
+<p:notesMaster xmlns:a="http://schemas.openxmlformats.org/drawingml/2006/main" xmlns:r="http://schemas.openxmlformats.org/officeDocument/2006/relationships" xmlns:p="http://schemas.openxmlformats.org/presentationml/2006/main">
+  <p:cSld>
+    <p:bg>
+      <p:bgRef idx="1001">
+        <a:schemeClr val="bg1"/>
+      </p:bgRef>
+    </p:bg>
+    <p:spTree>
+      <p:nvGrpSpPr>
+        <p:cNvPr id="1" name=""/>
+        <p:cNvGrpSpPr/>
+        <p:nvPr/>
+      </p:nvGrpSpPr>
+      <p:grpSpPr>
+        <a:xfrm>
+          <a:off x="0" y="0"/>
+          <a:ext cx="0" cy="0"/>
+          <a:chOff x="0" y="0"/>
+          <a:chExt cx="0" cy="0"/>
+        </a:xfrm>
+      </p:grpSpPr>
+      <p:sp>
+        <p:nvSpPr>
+          <p:cNvPr id="2" name="Header Placeholder 1"/>
+          <p:cNvSpPr>
+            <a:spLocks noGrp="1"/>
+          </p:cNvSpPr>
+          <p:nvPr>
+            <p:ph type="hdr" sz="quarter"/>
+          </p:nvPr>
+        </p:nvSpPr>
+        <p:spPr>
+          <a:xfrm>
+            <a:off x="0" y="0"/>
+            <a:ext cx="2971800" cy="458788"/>
+          </a:xfrm>
+          <a:prstGeom prst="rect">
+            <a:avLst/>
+          </a:prstGeom>
+        </p:spPr>
+        <p:txBody>
+          <a:bodyPr vert="horz" lIns="91440" tIns="45720" rIns="91440" bIns="45720" rtlCol="0"/>
+          <a:lstStyle>
+            <a:lvl1pPr algn="l">
+              <a:defRPr sz="1200"/>
+            </a:lvl1pPr>
+          </a:lstStyle>
+          <a:p>
+            <a:endParaRPr lang="en-IN"/>
+          </a:p>
+        </p:txBody>
+      </p:sp>
+      <p:sp>
+        <p:nvSpPr>
+          <p:cNvPr id="3" name="Date Placeholder 2"/>
+          <p:cNvSpPr>
+            <a:spLocks noGrp="1"/>
+          </p:cNvSpPr>
+          <p:nvPr>
+            <p:ph type="dt" idx="1"/>
+          </p:nvPr>
+        </p:nvSpPr>
+        <p:spPr>
+          <a:xfrm>
+            <a:off x="3884613" y="0"/>
+            <a:ext cx="2971800" cy="458788"/>
+          </a:xfrm>
+          <a:prstGeom prst="rect">
+            <a:avLst/>
+          </a:prstGeom>
+        </p:spPr>
+        <p:txBody>
+          <a:bodyPr vert="horz" lIns="91440" tIns="45720" rIns="91440" bIns="45720" rtlCol="0"/>
+          <a:lstStyle>
+            <a:lvl1pPr algn="r">
+              <a:defRPr sz="1200"/>
+            </a:lvl1pPr>
+          </a:lstStyle>
+          <a:p>
+            <a:fld id="{C620FECC-27C3-4231-A3EB-2E6A445D0E01}" type="datetimeFigureOut">
+              <a:rPr lang="en-IN" smtClean="0"/>
+              <a:t>27-10-2026</a:t>
+            </a:fld>
+            <a:endParaRPr lang="en-IN"/>
+          </a:p>
+        </p:txBody>
+      </p:sp>
+      <p:sp>
+        <p:nvSpPr>
+          <p:cNvPr id="4" name="Slide Image Placeholder 3"/>
+          <p:cNvSpPr>
+            <a:spLocks noGrp="1" noRot="1" noChangeAspect="1"/>
+          </p:cNvSpPr>
+          <p:nvPr>
+            <p:ph type="sldImg" idx="2"/>
+          </p:nvPr>
+        </p:nvSpPr>
+        <p:spPr>
+          <a:xfrm>
+            <a:off x="685800" y="1143000"/>
+            <a:ext cx="5486400" cy="3086100"/>
+          </a:xfrm>
+          <a:prstGeom prst="rect">
+            <a:avLst/>
+          </a:prstGeom>
+          <a:noFill/>
+          <a:ln w="12700">
+            <a:solidFill>
+              <a:prstClr val="black"/>
+            </a:solidFill>
+          </a:ln>
+        </p:spPr>
+        <p:txBody>
+          <a:bodyPr vert="horz" lIns="91440" tIns="45720" rIns="91440" bIns="45720" rtlCol="0" anchor="ctr"/>
+          <a:lstStyle/>
+          <a:p>
+            <a:endParaRPr lang="en-IN"/>
+          </a:p>
+        </p:txBody>
+      </p:sp>
+      <p:sp>
+        <p:nvSpPr>
+          <p:cNvPr id="5" name="Notes Placeholder 4"/>
+          <p:cNvSpPr>
+            <a:spLocks noGrp="1"/>
+          </p:cNvSpPr>
+          <p:nvPr>
+            <p:ph type="body" sz="quarter" idx="3"/>
+          </p:nvPr>
+        </p:nvSpPr>
+        <p:spPr>
+          <a:xfrm>
+            <a:off x="685800" y="4400550"/>
+            <a:ext cx="5486400" cy="3600450"/>
+          </a:xfrm>
+          <a:prstGeom prst="rect">
+            <a:avLst/>
+          </a:prstGeom>
+        </p:spPr>
+        <p:txBody>
+          <a:bodyPr vert="horz" lIns="91440" tIns="45720" rIns="91440" bIns="45720" rtlCol="0"/>
+          <a:lstStyle/>
+          <a:p>
+            <a:pPr lvl="0"/>
+            <a:r>
+              <a:rPr lang="en-GB"/>
+              <a:t>Click to edit Master text styles</a:t>
+            </a:r>
+          </a:p>
+          <a:p>
+            <a:pPr lvl="1"/>
+            <a:r>
+              <a:rPr lang="en-GB"/>
+              <a:t>Second level</a:t>
+            </a:r>
+          </a:p>
+          <a:p>
+            <a:pPr lvl="2"/>
+            <a:r>
+              <a:rPr lang="en-GB"/>
+              <a:t>Third level</a:t>
+            </a:r>
+          </a:p>
+          <a:p>
+            <a:pPr lvl="3"/>
+            <a:r>
+              <a:rPr lang="en-GB"/>
+              <a:t>Fourth level</a:t>
+            </a:r>
+          </a:p>
+          <a:p>
+            <a:pPr lvl="4"/>
+            <a:r>
+              <a:rPr lang="en-GB"/>
+              <a:t>Fifth level</a:t>
+            </a:r>
+            <a:endParaRPr lang="en-IN"/>
+          </a:p>
+        </p:txBody>
+      </p:sp>
+      <p:sp>
+        <p:nvSpPr>
+          <p:cNvPr id="6" name="Footer Placeholder 5"/>
+          <p:cNvSpPr>
+            <a:spLocks noGrp="1"/>
+          </p:cNvSpPr>
+          <p:nvPr>
+            <p:ph type="ftr" sz="quarter" idx="4"/>
+          </p:nvPr>
+        </p:nvSpPr>
+        <p:spPr>
+          <a:xfrm>
+            <a:off x="0" y="8685213"/>
+            <a:ext cx="2971800" cy="458787"/>
+          </a:xfrm>
+          <a:prstGeom prst="rect">
+            <a:avLst/>
+          </a:prstGeom>
+        </p:spPr>
+        <p:txBody>
+          <a:bodyPr vert="horz" lIns="91440" tIns="45720" rIns="91440" bIns="45720" rtlCol="0" anchor="b"/>
+          <a:lstStyle>
+            <a:lvl1pPr algn="l">
+              <a:defRPr sz="1200"/>
+            </a:lvl1pPr>
+          </a:lstStyle>
+          <a:p>
+            <a:endParaRPr lang="en-IN"/>
+          </a:p>
+        </p:txBody>
+      </p:sp>
+      <p:sp>
+        <p:nvSpPr>
+          <p:cNvPr id="7" name="Slide Number Placeholder 6"/>
+          <p:cNvSpPr>
+            <a:spLocks noGrp="1"/>
+          </p:cNvSpPr>
+          <p:nvPr>
+            <p:ph type="sldNum" sz="quarter" idx="5"/>
+          </p:nvPr>
+        </p:nvSpPr>
+        <p:spPr>
+          <a:xfrm>
+            <a:off x="3884613" y="8685213"/>
+            <a:ext cx="2971800" cy="458787"/>
+          </a:xfrm>
+          <a:prstGeom prst="rect">
+            <a:avLst/>
+          </a:prstGeom>
+        </p:spPr>
+        <p:txBody>
+          <a:bodyPr vert="horz" lIns="91440" tIns="45720" rIns="91440" bIns="45720" rtlCol="0" anchor="b"/>
+          <a:lstStyle>
+            <a:lvl1pPr algn="r">
+              <a:defRPr sz="1200"/>
+            </a:lvl1pPr>
+          </a:lstStyle>
+          <a:p>
+            <a:fld id="{302D5A53-C290-4B1D-A0F6-7B09613EA955}" type="slidenum">
+              <a:rPr lang="en-IN" smtClean="0"/>
+              <a:t>‹#›</a:t>
+            </a:fld>
+            <a:endParaRPr lang="en-IN"/>
+          </a:p>
+        </p:txBody>
+      </p:sp>
+    </p:spTree>
+    <p:extLst>
+      <p:ext uri="{BB962C8B-B14F-4D97-AF65-F5344CB8AC3E}">
+        <p14:creationId xmlns:p14="http://schemas.microsoft.com/office/powerpoint/2010/main" val="3307857664"/>
+      </p:ext>
+    </p:extLst>
+  </p:cSld>
+  <p:clrMap bg1="lt1" tx1="dk1" bg2="lt2" tx2="dk2" accent1="accent1" accent2="accent2" accent3="accent3" accent4="accent4" accent5="accent5" accent6="accent6" hlink="hlink" folHlink="folHlink"/>
+  <p:notesStyle>
+    <a:lvl1pPr marL="0" algn="l" defTabSz="914400" rtl="0" eaLnBrk="1" latinLnBrk="0" hangingPunct="1">
+      <a:defRPr sz="1200" kern="1200">
+        <a:solidFill>
+          <a:schemeClr val="tx1"/>
+        </a:solidFill>
+        <a:latin typeface="+mn-lt"/>
+        <a:ea typeface="+mn-ea"/>
+        <a:cs typeface="+mn-cs"/>
+      </a:defRPr>
+    </a:lvl1pPr>
+    <a:lvl2pPr marL="457200" algn="l" defTabSz="914400" rtl="0" eaLnBrk="1" latinLnBrk="0" hangingPunct="1">
+      <a:defRPr sz="1200" kern="1200">
+        <a:solidFill>
+          <a:schemeClr val="tx1"/>
+        </a:solidFill>
+        <a:latin typeface="+mn-lt"/>
+        <a:ea typeface="+mn-ea"/>
+        <a:cs typeface="+mn-cs"/>
+      </a:defRPr>
+    </a:lvl2pPr>
+    <a:lvl3pPr marL="914400" algn="l" defTabSz="914400" rtl="0" eaLnBrk="1" latinLnBrk="0" hangingPunct="1">
+      <a:defRPr sz="1200" kern="1200">
+        <a:solidFill>
+          <a:schemeClr val="tx1"/>
+        </a:solidFill>
+        <a:latin typeface="+mn-lt"/>
+        <a:ea typeface="+mn-ea"/>
+        <a:cs typeface="+mn-cs"/>
+      </a:defRPr>
+    </a:lvl3pPr>
+    <a:lvl4pPr marL="1371600" algn="l" defTabSz="914400" rtl="0" eaLnBrk="1" latinLnBrk="0" hangingPunct="1">
+      <a:defRPr sz="1200" kern="1200">
+        <a:solidFill>
+          <a:schemeClr val="tx1"/>
+        </a:solidFill>
+        <a:latin typeface="+mn-lt"/>
+        <a:ea typeface="+mn-ea"/>
+        <a:cs typeface="+mn-cs"/>
+      </a:defRPr>
+    </a:lvl4pPr>
+    <a:lvl5pPr marL="1828800" algn="l" defTabSz="914400" rtl="0" eaLnBrk="1" latinLnBrk="0" hangingPunct="1">
+      <a:defRPr sz="1200" kern="1200">
+        <a:solidFill>
+          <a:schemeClr val="tx1"/>
+        </a:solidFill>
+        <a:latin typeface="+mn-lt"/>
+        <a:ea typeface="+mn-ea"/>
+        <a:cs typeface="+mn-cs"/>
+      </a:defRPr>
+    </a:lvl5pPr>
+    <a:lvl6pPr marL="2286000" algn="l" defTabSz="914400" rtl="0" eaLnBrk="1" latinLnBrk="0" hangingPunct="1">
+      <a:defRPr sz="1200" kern="1200">
+        <a:solidFill>
+          <a:schemeClr val="tx1"/>
+        </a:solidFill>
+        <a:latin typeface="+mn-lt"/>
+        <a:ea typeface="+mn-ea"/>
+        <a:cs typeface="+mn-cs"/>
+      </a:defRPr>
+    </a:lvl6pPr>
+    <a:lvl7pPr marL="2743200" algn="l" defTabSz="914400" rtl="0" eaLnBrk="1" latinLnBrk="0" hangingPunct="1">
+      <a:defRPr sz="1200" kern="1200">
+        <a:solidFill>
+          <a:schemeClr val="tx1"/>
+        </a:solidFill>
+        <a:latin typeface="+mn-lt"/>
+        <a:ea typeface="+mn-ea"/>
+        <a:cs typeface="+mn-cs"/>
+      </a:defRPr>
+    </a:lvl7pPr>
+    <a:lvl8pPr marL="3200400" algn="l" defTabSz="914400" rtl="0" eaLnBrk="1" latinLnBrk="0" hangingPunct="1">
+      <a:defRPr sz="1200" kern="1200">
+        <a:solidFill>
+          <a:schemeClr val="tx1"/>
+        </a:solidFill>
+        <a:latin typeface="+mn-lt"/>
+        <a:ea typeface="+mn-ea"/>
+        <a:cs typeface="+mn-cs"/>
+      </a:defRPr>
+    </a:lvl8pPr>
+    <a:lvl9pPr marL="3657600" algn="l" defTabSz="914400" rtl="0" eaLnBrk="1" latinLnBrk="0" hangingPunct="1">
+      <a:defRPr sz="1200" kern="1200">
+        <a:solidFill>
+          <a:schemeClr val="tx1"/>
+        </a:solidFill>
+        <a:latin typeface="+mn-lt"/>
+        <a:ea typeface="+mn-ea"/>
+        <a:cs typeface="+mn-cs"/>
+      </a:defRPr>
+    </a:lvl9pPr>
+  </p:notesStyle>
+</p:notesMaster>
+</file>
+
+<file path=ppt/notesSlides/notesSlide1.xml><?xml version="1.0" encoding="utf-8"?>
+<p:notes xmlns:a="http://schemas.openxmlformats.org/drawingml/2006/main" xmlns:r="http://schemas.openxmlformats.org/officeDocument/2006/relationships" xmlns:p="http://schemas.openxmlformats.org/presentationml/2006/main">
+  <p:cSld>
+    <p:spTree>
+      <p:nvGrpSpPr>
+        <p:cNvPr id="1" name=""/>
+        <p:cNvGrpSpPr/>
+        <p:nvPr/>
+      </p:nvGrpSpPr>
+      <p:grpSpPr>
+        <a:xfrm>
+          <a:off x="0" y="0"/>
+          <a:ext cx="0" cy="0"/>
+          <a:chOff x="0" y="0"/>
+          <a:chExt cx="0" cy="0"/>
+        </a:xfrm>
+      </p:grpSpPr>
+      <p:sp>
+        <p:nvSpPr>
+          <p:cNvPr id="2" name="Slide Image Placeholder 1"/>
+          <p:cNvSpPr>
+            <a:spLocks noGrp="1" noRot="1" noChangeAspect="1"/>
+          </p:cNvSpPr>
+          <p:nvPr>
+            <p:ph type="sldImg"/>
+          </p:nvPr>
+        </p:nvSpPr>
+        <p:spPr/>
+      </p:sp>
+      <p:sp>
+        <p:nvSpPr>
+          <p:cNvPr id="3" name="Notes Placeholder 2"/>
+          <p:cNvSpPr>
+            <a:spLocks noGrp="1"/>
+          </p:cNvSpPr>
+          <p:nvPr>
+            <p:ph type="body" idx="1"/>
+          </p:nvPr>
+        </p:nvSpPr>
+        <p:spPr/>
+        <p:txBody>
+          <a:bodyPr/>
+          <a:lstStyle/>
+          <a:p>
+            <a:r>
+              <a:rPr lang="en-US" dirty="0"/>
+              <a:t>The objective is to create a modern, mobile-friendly customer interface while continuing to use the existing Juice Robo e-commerce backend.”</a:t>
+            </a:r>
+          </a:p>
+          <a:p>
+            <a:endParaRPr lang="en-IN" dirty="0"/>
+          </a:p>
+        </p:txBody>
+      </p:sp>
+      <p:sp>
+        <p:nvSpPr>
+          <p:cNvPr id="4" name="Slide Number Placeholder 3"/>
+          <p:cNvSpPr>
+            <a:spLocks noGrp="1"/>
+          </p:cNvSpPr>
+          <p:nvPr>
+            <p:ph type="sldNum" sz="quarter" idx="5"/>
+          </p:nvPr>
+        </p:nvSpPr>
+        <p:spPr/>
+        <p:txBody>
+          <a:bodyPr/>
+          <a:lstStyle/>
+          <a:p>
+            <a:fld id="{302D5A53-C290-4B1D-A0F6-7B09613EA955}" type="slidenum">
+              <a:rPr lang="en-IN" smtClean="0"/>
+              <a:t>1</a:t>
+            </a:fld>
+            <a:endParaRPr lang="en-IN"/>
+          </a:p>
+        </p:txBody>
+      </p:sp>
+    </p:spTree>
+    <p:extLst>
+      <p:ext uri="{BB962C8B-B14F-4D97-AF65-F5344CB8AC3E}">
+        <p14:creationId xmlns:p14="http://schemas.microsoft.com/office/powerpoint/2010/main" val="1940793973"/>
+      </p:ext>
+    </p:extLst>
+  </p:cSld>
+  <p:clrMapOvr>
+    <a:masterClrMapping/>
+  </p:clrMapOvr>
+</p:notes>
+</file>
+
+<file path=ppt/notesSlides/notesSlide2.xml><?xml version="1.0" encoding="utf-8"?>
+<p:notes xmlns:a="http://schemas.openxmlformats.org/drawingml/2006/main" xmlns:r="http://schemas.openxmlformats.org/officeDocument/2006/relationships" xmlns:p="http://schemas.openxmlformats.org/presentationml/2006/main">
+  <p:cSld>
+    <p:spTree>
+      <p:nvGrpSpPr>
+        <p:cNvPr id="1" name=""/>
+        <p:cNvGrpSpPr/>
+        <p:nvPr/>
+      </p:nvGrpSpPr>
+      <p:grpSpPr>
+        <a:xfrm>
+          <a:off x="0" y="0"/>
+          <a:ext cx="0" cy="0"/>
+          <a:chOff x="0" y="0"/>
+          <a:chExt cx="0" cy="0"/>
+        </a:xfrm>
+      </p:grpSpPr>
+      <p:sp>
+        <p:nvSpPr>
+          <p:cNvPr id="2" name="Slide Image Placeholder 1"/>
+          <p:cNvSpPr>
+            <a:spLocks noGrp="1" noRot="1" noChangeAspect="1"/>
+          </p:cNvSpPr>
+          <p:nvPr>
+            <p:ph type="sldImg"/>
+          </p:nvPr>
+        </p:nvSpPr>
+        <p:spPr/>
+      </p:sp>
+      <p:sp>
+        <p:nvSpPr>
+          <p:cNvPr id="3" name="Notes Placeholder 2"/>
+          <p:cNvSpPr>
+            <a:spLocks noGrp="1"/>
+          </p:cNvSpPr>
+          <p:nvPr>
+            <p:ph type="body" idx="1"/>
+          </p:nvPr>
+        </p:nvSpPr>
+        <p:spPr/>
+        <p:txBody>
+          <a:bodyPr/>
+          <a:lstStyle/>
+          <a:p>
+            <a:r>
+              <a:rPr lang="en-US" dirty="0"/>
+              <a:t>Our scope is to redesign the existing frontend without replacing the backend. We are reusing the existing APIs, business logic, and order-processing system while improving the user interface, navigation, and overall customer experience.</a:t>
+            </a:r>
+            <a:endParaRPr lang="en-IN" dirty="0"/>
+          </a:p>
+        </p:txBody>
+      </p:sp>
+      <p:sp>
+        <p:nvSpPr>
+          <p:cNvPr id="4" name="Slide Number Placeholder 3"/>
+          <p:cNvSpPr>
+            <a:spLocks noGrp="1"/>
+          </p:cNvSpPr>
+          <p:nvPr>
+            <p:ph type="sldNum" sz="quarter" idx="5"/>
+          </p:nvPr>
+        </p:nvSpPr>
+        <p:spPr/>
+        <p:txBody>
+          <a:bodyPr/>
+          <a:lstStyle/>
+          <a:p>
+            <a:fld id="{302D5A53-C290-4B1D-A0F6-7B09613EA955}" type="slidenum">
+              <a:rPr lang="en-IN" smtClean="0"/>
+              <a:t>2</a:t>
+            </a:fld>
+            <a:endParaRPr lang="en-IN"/>
+          </a:p>
+        </p:txBody>
+      </p:sp>
+    </p:spTree>
+    <p:extLst>
+      <p:ext uri="{BB962C8B-B14F-4D97-AF65-F5344CB8AC3E}">
+        <p14:creationId xmlns:p14="http://schemas.microsoft.com/office/powerpoint/2010/main" val="2813462178"/>
+      </p:ext>
+    </p:extLst>
+  </p:cSld>
+  <p:clrMapOvr>
+    <a:masterClrMapping/>
+  </p:clrMapOvr>
+</p:notes>
+</file>
+
+<file path=ppt/notesSlides/notesSlide3.xml><?xml version="1.0" encoding="utf-8"?>
+<p:notes xmlns:a="http://schemas.openxmlformats.org/drawingml/2006/main" xmlns:r="http://schemas.openxmlformats.org/officeDocument/2006/relationships" xmlns:p="http://schemas.openxmlformats.org/presentationml/2006/main">
+  <p:cSld>
+    <p:spTree>
+      <p:nvGrpSpPr>
+        <p:cNvPr id="1" name=""/>
+        <p:cNvGrpSpPr/>
+        <p:nvPr/>
+      </p:nvGrpSpPr>
+      <p:grpSpPr>
+        <a:xfrm>
+          <a:off x="0" y="0"/>
+          <a:ext cx="0" cy="0"/>
+          <a:chOff x="0" y="0"/>
+          <a:chExt cx="0" cy="0"/>
+        </a:xfrm>
+      </p:grpSpPr>
+      <p:sp>
+        <p:nvSpPr>
+          <p:cNvPr id="2" name="Slide Image Placeholder 1"/>
+          <p:cNvSpPr>
+            <a:spLocks noGrp="1" noRot="1" noChangeAspect="1"/>
+          </p:cNvSpPr>
+          <p:nvPr>
+            <p:ph type="sldImg"/>
+          </p:nvPr>
+        </p:nvSpPr>
+        <p:spPr/>
+      </p:sp>
+      <p:sp>
+        <p:nvSpPr>
+          <p:cNvPr id="3" name="Notes Placeholder 2"/>
+          <p:cNvSpPr>
+            <a:spLocks noGrp="1"/>
+          </p:cNvSpPr>
+          <p:nvPr>
+            <p:ph type="body" idx="1"/>
+          </p:nvPr>
+        </p:nvSpPr>
+        <p:spPr/>
+        <p:txBody>
+          <a:bodyPr/>
+          <a:lstStyle/>
+          <a:p>
+            <a:r>
+              <a:rPr lang="en-US" dirty="0"/>
+              <a:t>The frontend communicates with the existing backend through APIs. These APIs retrieve outlet and menu information, synchronize cart data, submit orders, and check payment status. The backend continues to manage data storage, business logic, order processing, and payment verification.</a:t>
+            </a:r>
+            <a:endParaRPr lang="en-IN" dirty="0"/>
+          </a:p>
+        </p:txBody>
+      </p:sp>
+      <p:sp>
+        <p:nvSpPr>
+          <p:cNvPr id="4" name="Slide Number Placeholder 3"/>
+          <p:cNvSpPr>
+            <a:spLocks noGrp="1"/>
+          </p:cNvSpPr>
+          <p:nvPr>
+            <p:ph type="sldNum" sz="quarter" idx="5"/>
+          </p:nvPr>
+        </p:nvSpPr>
+        <p:spPr/>
+        <p:txBody>
+          <a:bodyPr/>
+          <a:lstStyle/>
+          <a:p>
+            <a:fld id="{302D5A53-C290-4B1D-A0F6-7B09613EA955}" type="slidenum">
+              <a:rPr lang="en-IN" smtClean="0"/>
+              <a:t>3</a:t>
+            </a:fld>
+            <a:endParaRPr lang="en-IN"/>
+          </a:p>
+        </p:txBody>
+      </p:sp>
+    </p:spTree>
+    <p:extLst>
+      <p:ext uri="{BB962C8B-B14F-4D97-AF65-F5344CB8AC3E}">
+        <p14:creationId xmlns:p14="http://schemas.microsoft.com/office/powerpoint/2010/main" val="2165175799"/>
+      </p:ext>
+    </p:extLst>
+  </p:cSld>
+  <p:clrMapOvr>
+    <a:masterClrMapping/>
+  </p:clrMapOvr>
+</p:notes>
+</file>
+
+<file path=ppt/notesSlides/notesSlide4.xml><?xml version="1.0" encoding="utf-8"?>
+<p:notes xmlns:a="http://schemas.openxmlformats.org/drawingml/2006/main" xmlns:r="http://schemas.openxmlformats.org/officeDocument/2006/relationships" xmlns:p="http://schemas.openxmlformats.org/presentationml/2006/main">
+  <p:cSld>
+    <p:spTree>
+      <p:nvGrpSpPr>
+        <p:cNvPr id="1" name=""/>
+        <p:cNvGrpSpPr/>
+        <p:nvPr/>
+      </p:nvGrpSpPr>
+      <p:grpSpPr>
+        <a:xfrm>
+          <a:off x="0" y="0"/>
+          <a:ext cx="0" cy="0"/>
+          <a:chOff x="0" y="0"/>
+          <a:chExt cx="0" cy="0"/>
+        </a:xfrm>
+      </p:grpSpPr>
+      <p:sp>
+        <p:nvSpPr>
+          <p:cNvPr id="2" name="Slide Image Placeholder 1"/>
+          <p:cNvSpPr>
+            <a:spLocks noGrp="1" noRot="1" noChangeAspect="1"/>
+          </p:cNvSpPr>
+          <p:nvPr>
+            <p:ph type="sldImg"/>
+          </p:nvPr>
+        </p:nvSpPr>
+        <p:spPr/>
+      </p:sp>
+      <p:sp>
+        <p:nvSpPr>
+          <p:cNvPr id="3" name="Notes Placeholder 2"/>
+          <p:cNvSpPr>
+            <a:spLocks noGrp="1"/>
+          </p:cNvSpPr>
+          <p:nvPr>
+            <p:ph type="body" idx="1"/>
+          </p:nvPr>
+        </p:nvSpPr>
+        <p:spPr/>
+        <p:txBody>
+          <a:bodyPr/>
+          <a:lstStyle/>
+          <a:p>
+            <a:r>
+              <a:rPr lang="en-US" dirty="0"/>
+              <a:t>“We implemented QR-based outlet access to simplify the customer journey. When customers scan the Juice Robo QR code, the frontend extracts the relevant outlet or menu identifier from the URL and uses the existing APIs to load the corresponding menu.</a:t>
+            </a:r>
+            <a:endParaRPr lang="en-IN" dirty="0"/>
+          </a:p>
+        </p:txBody>
+      </p:sp>
+      <p:sp>
+        <p:nvSpPr>
+          <p:cNvPr id="4" name="Slide Number Placeholder 3"/>
+          <p:cNvSpPr>
+            <a:spLocks noGrp="1"/>
+          </p:cNvSpPr>
+          <p:nvPr>
+            <p:ph type="sldNum" sz="quarter" idx="5"/>
+          </p:nvPr>
+        </p:nvSpPr>
+        <p:spPr/>
+        <p:txBody>
+          <a:bodyPr/>
+          <a:lstStyle/>
+          <a:p>
+            <a:fld id="{302D5A53-C290-4B1D-A0F6-7B09613EA955}" type="slidenum">
+              <a:rPr lang="en-IN" smtClean="0"/>
+              <a:t>4</a:t>
+            </a:fld>
+            <a:endParaRPr lang="en-IN"/>
+          </a:p>
+        </p:txBody>
+      </p:sp>
+    </p:spTree>
+    <p:extLst>
+      <p:ext uri="{BB962C8B-B14F-4D97-AF65-F5344CB8AC3E}">
+        <p14:creationId xmlns:p14="http://schemas.microsoft.com/office/powerpoint/2010/main" val="1783251308"/>
+      </p:ext>
+    </p:extLst>
+  </p:cSld>
+  <p:clrMapOvr>
+    <a:masterClrMapping/>
+  </p:clrMapOvr>
+</p:notes>
+</file>
+
+<file path=ppt/notesSlides/notesSlide5.xml><?xml version="1.0" encoding="utf-8"?>
+<p:notes xmlns:a="http://schemas.openxmlformats.org/drawingml/2006/main" xmlns:r="http://schemas.openxmlformats.org/officeDocument/2006/relationships" xmlns:p="http://schemas.openxmlformats.org/presentationml/2006/main">
+  <p:cSld>
+    <p:spTree>
+      <p:nvGrpSpPr>
+        <p:cNvPr id="1" name=""/>
+        <p:cNvGrpSpPr/>
+        <p:nvPr/>
+      </p:nvGrpSpPr>
+      <p:grpSpPr>
+        <a:xfrm>
+          <a:off x="0" y="0"/>
+          <a:ext cx="0" cy="0"/>
+          <a:chOff x="0" y="0"/>
+          <a:chExt cx="0" cy="0"/>
+        </a:xfrm>
+      </p:grpSpPr>
+      <p:sp>
+        <p:nvSpPr>
+          <p:cNvPr id="2" name="Slide Image Placeholder 1"/>
+          <p:cNvSpPr>
+            <a:spLocks noGrp="1" noRot="1" noChangeAspect="1"/>
+          </p:cNvSpPr>
+          <p:nvPr>
+            <p:ph type="sldImg"/>
+          </p:nvPr>
+        </p:nvSpPr>
+        <p:spPr/>
+      </p:sp>
+      <p:sp>
+        <p:nvSpPr>
+          <p:cNvPr id="3" name="Notes Placeholder 2"/>
+          <p:cNvSpPr>
+            <a:spLocks noGrp="1"/>
+          </p:cNvSpPr>
+          <p:nvPr>
+            <p:ph type="body" idx="1"/>
+          </p:nvPr>
+        </p:nvSpPr>
+        <p:spPr/>
+        <p:txBody>
+          <a:bodyPr/>
+          <a:lstStyle/>
+          <a:p>
+            <a:r>
+              <a:rPr lang="en-US" dirty="0"/>
+              <a:t>We redesigned the menu screen to provide a cleaner and more intuitive browsing experience. Product images, names, and prices are displayed clearly, allowing customers to browse products and add items to their cart. The product information continues to come from the existing backend APIs.</a:t>
+            </a:r>
+            <a:endParaRPr lang="en-IN" dirty="0"/>
+          </a:p>
+        </p:txBody>
+      </p:sp>
+      <p:sp>
+        <p:nvSpPr>
+          <p:cNvPr id="4" name="Slide Number Placeholder 3"/>
+          <p:cNvSpPr>
+            <a:spLocks noGrp="1"/>
+          </p:cNvSpPr>
+          <p:nvPr>
+            <p:ph type="sldNum" sz="quarter" idx="5"/>
+          </p:nvPr>
+        </p:nvSpPr>
+        <p:spPr/>
+        <p:txBody>
+          <a:bodyPr/>
+          <a:lstStyle/>
+          <a:p>
+            <a:fld id="{302D5A53-C290-4B1D-A0F6-7B09613EA955}" type="slidenum">
+              <a:rPr lang="en-IN" smtClean="0"/>
+              <a:t>5</a:t>
+            </a:fld>
+            <a:endParaRPr lang="en-IN"/>
+          </a:p>
+        </p:txBody>
+      </p:sp>
+    </p:spTree>
+    <p:extLst>
+      <p:ext uri="{BB962C8B-B14F-4D97-AF65-F5344CB8AC3E}">
+        <p14:creationId xmlns:p14="http://schemas.microsoft.com/office/powerpoint/2010/main" val="1559711048"/>
+      </p:ext>
+    </p:extLst>
+  </p:cSld>
+  <p:clrMapOvr>
+    <a:masterClrMapping/>
+  </p:clrMapOvr>
+</p:notes>
+</file>
+
+<file path=ppt/notesSlides/notesSlide6.xml><?xml version="1.0" encoding="utf-8"?>
+<p:notes xmlns:a="http://schemas.openxmlformats.org/drawingml/2006/main" xmlns:r="http://schemas.openxmlformats.org/officeDocument/2006/relationships" xmlns:p="http://schemas.openxmlformats.org/presentationml/2006/main">
+  <p:cSld>
+    <p:spTree>
+      <p:nvGrpSpPr>
+        <p:cNvPr id="1" name=""/>
+        <p:cNvGrpSpPr/>
+        <p:nvPr/>
+      </p:nvGrpSpPr>
+      <p:grpSpPr>
+        <a:xfrm>
+          <a:off x="0" y="0"/>
+          <a:ext cx="0" cy="0"/>
+          <a:chOff x="0" y="0"/>
+          <a:chExt cx="0" cy="0"/>
+        </a:xfrm>
+      </p:grpSpPr>
+      <p:sp>
+        <p:nvSpPr>
+          <p:cNvPr id="2" name="Slide Image Placeholder 1"/>
+          <p:cNvSpPr>
+            <a:spLocks noGrp="1" noRot="1" noChangeAspect="1"/>
+          </p:cNvSpPr>
+          <p:nvPr>
+            <p:ph type="sldImg"/>
+          </p:nvPr>
+        </p:nvSpPr>
+        <p:spPr/>
+      </p:sp>
+      <p:sp>
+        <p:nvSpPr>
+          <p:cNvPr id="3" name="Notes Placeholder 2"/>
+          <p:cNvSpPr>
+            <a:spLocks noGrp="1"/>
+          </p:cNvSpPr>
+          <p:nvPr>
+            <p:ph type="body" idx="1"/>
+          </p:nvPr>
+        </p:nvSpPr>
+        <p:spPr/>
+        <p:txBody>
+          <a:bodyPr/>
+          <a:lstStyle/>
+          <a:p>
+            <a:r>
+              <a:rPr lang="en-US" dirty="0"/>
+              <a:t>The redesigned cart allows customers to review selected products and manage quantities. We improved the checkout screen to display order details, applicable GST, and the final payable amount clearly. Cart operations are synchronized with the backend to maintain consistency throughout the ordering process.</a:t>
+            </a:r>
+            <a:endParaRPr lang="en-IN" dirty="0"/>
+          </a:p>
+        </p:txBody>
+      </p:sp>
+      <p:sp>
+        <p:nvSpPr>
+          <p:cNvPr id="4" name="Slide Number Placeholder 3"/>
+          <p:cNvSpPr>
+            <a:spLocks noGrp="1"/>
+          </p:cNvSpPr>
+          <p:nvPr>
+            <p:ph type="sldNum" sz="quarter" idx="5"/>
+          </p:nvPr>
+        </p:nvSpPr>
+        <p:spPr/>
+        <p:txBody>
+          <a:bodyPr/>
+          <a:lstStyle/>
+          <a:p>
+            <a:fld id="{302D5A53-C290-4B1D-A0F6-7B09613EA955}" type="slidenum">
+              <a:rPr lang="en-IN" smtClean="0"/>
+              <a:t>6</a:t>
+            </a:fld>
+            <a:endParaRPr lang="en-IN"/>
+          </a:p>
+        </p:txBody>
+      </p:sp>
+    </p:spTree>
+    <p:extLst>
+      <p:ext uri="{BB962C8B-B14F-4D97-AF65-F5344CB8AC3E}">
+        <p14:creationId xmlns:p14="http://schemas.microsoft.com/office/powerpoint/2010/main" val="2160897969"/>
+      </p:ext>
+    </p:extLst>
+  </p:cSld>
+  <p:clrMapOvr>
+    <a:masterClrMapping/>
+  </p:clrMapOvr>
+</p:notes>
+</file>
+
+<file path=ppt/notesSlides/notesSlide7.xml><?xml version="1.0" encoding="utf-8"?>
+<p:notes xmlns:a="http://schemas.openxmlformats.org/drawingml/2006/main" xmlns:r="http://schemas.openxmlformats.org/officeDocument/2006/relationships" xmlns:p="http://schemas.openxmlformats.org/presentationml/2006/main">
+  <p:cSld>
+    <p:spTree>
+      <p:nvGrpSpPr>
+        <p:cNvPr id="1" name=""/>
+        <p:cNvGrpSpPr/>
+        <p:nvPr/>
+      </p:nvGrpSpPr>
+      <p:grpSpPr>
+        <a:xfrm>
+          <a:off x="0" y="0"/>
+          <a:ext cx="0" cy="0"/>
+          <a:chOff x="0" y="0"/>
+          <a:chExt cx="0" cy="0"/>
+        </a:xfrm>
+      </p:grpSpPr>
+      <p:sp>
+        <p:nvSpPr>
+          <p:cNvPr id="2" name="Slide Image Placeholder 1"/>
+          <p:cNvSpPr>
+            <a:spLocks noGrp="1" noRot="1" noChangeAspect="1"/>
+          </p:cNvSpPr>
+          <p:nvPr>
+            <p:ph type="sldImg"/>
+          </p:nvPr>
+        </p:nvSpPr>
+        <p:spPr/>
+      </p:sp>
+      <p:sp>
+        <p:nvSpPr>
+          <p:cNvPr id="3" name="Notes Placeholder 2"/>
+          <p:cNvSpPr>
+            <a:spLocks noGrp="1"/>
+          </p:cNvSpPr>
+          <p:nvPr>
+            <p:ph type="body" idx="1"/>
+          </p:nvPr>
+        </p:nvSpPr>
+        <p:spPr/>
+        <p:txBody>
+          <a:bodyPr/>
+          <a:lstStyle/>
+          <a:p>
+            <a:r>
+              <a:rPr lang="en-US" dirty="0"/>
+              <a:t>The Profile Screen displays the customer’s registered name and email address using authenticated account data. These details cannot be edited after account creation. Customers can access the My Orders section to view their orders and sign out.</a:t>
+            </a:r>
+          </a:p>
+          <a:p>
+            <a:r>
+              <a:rPr lang="en-US" dirty="0"/>
+              <a:t>Need to do – Giving Menu access </a:t>
+            </a:r>
+            <a:r>
+              <a:rPr lang="en-US"/>
+              <a:t>without login.</a:t>
+            </a:r>
+            <a:endParaRPr lang="en-IN" dirty="0"/>
+          </a:p>
+        </p:txBody>
+      </p:sp>
+      <p:sp>
+        <p:nvSpPr>
+          <p:cNvPr id="4" name="Slide Number Placeholder 3"/>
+          <p:cNvSpPr>
+            <a:spLocks noGrp="1"/>
+          </p:cNvSpPr>
+          <p:nvPr>
+            <p:ph type="sldNum" sz="quarter" idx="5"/>
+          </p:nvPr>
+        </p:nvSpPr>
+        <p:spPr/>
+        <p:txBody>
+          <a:bodyPr/>
+          <a:lstStyle/>
+          <a:p>
+            <a:fld id="{302D5A53-C290-4B1D-A0F6-7B09613EA955}" type="slidenum">
+              <a:rPr lang="en-IN" smtClean="0"/>
+              <a:t>7</a:t>
+            </a:fld>
+            <a:endParaRPr lang="en-IN"/>
+          </a:p>
+        </p:txBody>
+      </p:sp>
+    </p:spTree>
+    <p:extLst>
+      <p:ext uri="{BB962C8B-B14F-4D97-AF65-F5344CB8AC3E}">
+        <p14:creationId xmlns:p14="http://schemas.microsoft.com/office/powerpoint/2010/main" val="1737418523"/>
+      </p:ext>
+    </p:extLst>
+  </p:cSld>
+  <p:clrMapOvr>
+    <a:masterClrMapping/>
+  </p:clrMapOvr>
+</p:notes>
+</file>
+
+<file path=ppt/notesSlides/notesSlide8.xml><?xml version="1.0" encoding="utf-8"?>
+<p:notes xmlns:a="http://schemas.openxmlformats.org/drawingml/2006/main" xmlns:r="http://schemas.openxmlformats.org/officeDocument/2006/relationships" xmlns:p="http://schemas.openxmlformats.org/presentationml/2006/main">
+  <p:cSld>
+    <p:spTree>
+      <p:nvGrpSpPr>
+        <p:cNvPr id="1" name=""/>
+        <p:cNvGrpSpPr/>
+        <p:nvPr/>
+      </p:nvGrpSpPr>
+      <p:grpSpPr>
+        <a:xfrm>
+          <a:off x="0" y="0"/>
+          <a:ext cx="0" cy="0"/>
+          <a:chOff x="0" y="0"/>
+          <a:chExt cx="0" cy="0"/>
+        </a:xfrm>
+      </p:grpSpPr>
+      <p:sp>
+        <p:nvSpPr>
+          <p:cNvPr id="2" name="Slide Image Placeholder 1"/>
+          <p:cNvSpPr>
+            <a:spLocks noGrp="1" noRot="1" noChangeAspect="1"/>
+          </p:cNvSpPr>
+          <p:nvPr>
+            <p:ph type="sldImg"/>
+          </p:nvPr>
+        </p:nvSpPr>
+        <p:spPr/>
+      </p:sp>
+      <p:sp>
+        <p:nvSpPr>
+          <p:cNvPr id="3" name="Notes Placeholder 2"/>
+          <p:cNvSpPr>
+            <a:spLocks noGrp="1"/>
+          </p:cNvSpPr>
+          <p:nvPr>
+            <p:ph type="body" idx="1"/>
+          </p:nvPr>
+        </p:nvSpPr>
+        <p:spPr/>
+        <p:txBody>
+          <a:bodyPr/>
+          <a:lstStyle/>
+          <a:p>
+            <a:r>
+              <a:rPr lang="en-US" dirty="0"/>
+              <a:t>We improved the payment flow to support payments through the customer’s preferred UPI application. After payment is initiated, the frontend checks the order and payment status through the existing backend APIs. The payment success screen appears only after the backend confirms successful payment. Once the order is confirmed, the customer receives a unique four-digit pickup code to collect the order.</a:t>
+            </a:r>
+            <a:endParaRPr lang="en-IN" dirty="0"/>
+          </a:p>
+        </p:txBody>
+      </p:sp>
+      <p:sp>
+        <p:nvSpPr>
+          <p:cNvPr id="4" name="Slide Number Placeholder 3"/>
+          <p:cNvSpPr>
+            <a:spLocks noGrp="1"/>
+          </p:cNvSpPr>
+          <p:nvPr>
+            <p:ph type="sldNum" sz="quarter" idx="5"/>
+          </p:nvPr>
+        </p:nvSpPr>
+        <p:spPr/>
+        <p:txBody>
+          <a:bodyPr/>
+          <a:lstStyle/>
+          <a:p>
+            <a:fld id="{302D5A53-C290-4B1D-A0F6-7B09613EA955}" type="slidenum">
+              <a:rPr lang="en-IN" smtClean="0"/>
+              <a:t>8</a:t>
+            </a:fld>
+            <a:endParaRPr lang="en-IN"/>
+          </a:p>
+        </p:txBody>
+      </p:sp>
+    </p:spTree>
+    <p:extLst>
+      <p:ext uri="{BB962C8B-B14F-4D97-AF65-F5344CB8AC3E}">
+        <p14:creationId xmlns:p14="http://schemas.microsoft.com/office/powerpoint/2010/main" val="2724035993"/>
+      </p:ext>
+    </p:extLst>
+  </p:cSld>
+  <p:clrMapOvr>
+    <a:masterClrMapping/>
+  </p:clrMapOvr>
+</p:notes>
 </file>
 
 <file path=ppt/slideLayouts/slideLayout1.xml><?xml version="1.0" encoding="utf-8"?>
@@ -152,10 +1237,9 @@
           <a:lstStyle/>
           <a:p>
             <a:r>
-              <a:rPr lang="en-US" smtClean="0"/>
+              <a:rPr lang="en-US"/>
               <a:t>Click to edit Master title style</a:t>
             </a:r>
-            <a:endParaRPr lang="en-US"/>
           </a:p>
         </p:txBody>
       </p:sp>
@@ -271,10 +1355,9 @@
           </a:lstStyle>
           <a:p>
             <a:r>
-              <a:rPr lang="en-US" smtClean="0"/>
+              <a:rPr lang="en-US"/>
               <a:t>Click to edit Master subtitle style</a:t>
             </a:r>
-            <a:endParaRPr lang="en-US"/>
           </a:p>
         </p:txBody>
       </p:sp>
@@ -295,7 +1378,7 @@
           <a:p>
             <a:fld id="{5BCAD085-E8A6-8845-BD4E-CB4CCA059FC4}" type="datetimeFigureOut">
               <a:rPr lang="en-US" smtClean="0"/>
-              <a:t>1/27/13</a:t>
+              <a:t>10/27/2026</a:t>
             </a:fld>
             <a:endParaRPr lang="en-US"/>
           </a:p>
@@ -353,6 +1436,18 @@
   <p:clrMapOvr>
     <a:masterClrMapping/>
   </p:clrMapOvr>
+  <mc:AlternateContent xmlns:mc="http://schemas.openxmlformats.org/markup-compatibility/2006" xmlns:p14="http://schemas.microsoft.com/office/powerpoint/2010/main">
+    <mc:Choice Requires="p14">
+      <p:transition spd="med" p14:dur="700">
+        <p:fade/>
+      </p:transition>
+    </mc:Choice>
+    <mc:Fallback xmlns="">
+      <p:transition spd="med">
+        <p:fade/>
+      </p:transition>
+    </mc:Fallback>
+  </mc:AlternateContent>
 </p:sldLayout>
 </file>
 
@@ -389,10 +1484,9 @@
           <a:lstStyle/>
           <a:p>
             <a:r>
-              <a:rPr lang="en-US" smtClean="0"/>
+              <a:rPr lang="en-US"/>
               <a:t>Click to edit Master title style</a:t>
             </a:r>
-            <a:endParaRPr lang="en-US"/>
           </a:p>
         </p:txBody>
       </p:sp>
@@ -413,38 +1507,37 @@
           <a:p>
             <a:pPr lvl="0"/>
             <a:r>
-              <a:rPr lang="en-US" smtClean="0"/>
+              <a:rPr lang="en-US"/>
               <a:t>Click to edit Master text styles</a:t>
             </a:r>
           </a:p>
           <a:p>
             <a:pPr lvl="1"/>
             <a:r>
-              <a:rPr lang="en-US" smtClean="0"/>
+              <a:rPr lang="en-US"/>
               <a:t>Second level</a:t>
             </a:r>
           </a:p>
           <a:p>
             <a:pPr lvl="2"/>
             <a:r>
-              <a:rPr lang="en-US" smtClean="0"/>
+              <a:rPr lang="en-US"/>
               <a:t>Third level</a:t>
             </a:r>
           </a:p>
           <a:p>
             <a:pPr lvl="3"/>
             <a:r>
-              <a:rPr lang="en-US" smtClean="0"/>
+              <a:rPr lang="en-US"/>
               <a:t>Fourth level</a:t>
             </a:r>
           </a:p>
           <a:p>
             <a:pPr lvl="4"/>
             <a:r>
-              <a:rPr lang="en-US" smtClean="0"/>
+              <a:rPr lang="en-US"/>
               <a:t>Fifth level</a:t>
             </a:r>
-            <a:endParaRPr lang="en-US"/>
           </a:p>
         </p:txBody>
       </p:sp>
@@ -465,7 +1558,7 @@
           <a:p>
             <a:fld id="{5BCAD085-E8A6-8845-BD4E-CB4CCA059FC4}" type="datetimeFigureOut">
               <a:rPr lang="en-US" smtClean="0"/>
-              <a:t>1/27/13</a:t>
+              <a:t>10/27/2026</a:t>
             </a:fld>
             <a:endParaRPr lang="en-US"/>
           </a:p>
@@ -523,6 +1616,18 @@
   <p:clrMapOvr>
     <a:masterClrMapping/>
   </p:clrMapOvr>
+  <mc:AlternateContent xmlns:mc="http://schemas.openxmlformats.org/markup-compatibility/2006" xmlns:p14="http://schemas.microsoft.com/office/powerpoint/2010/main">
+    <mc:Choice Requires="p14">
+      <p:transition spd="med" p14:dur="700">
+        <p:fade/>
+      </p:transition>
+    </mc:Choice>
+    <mc:Fallback xmlns="">
+      <p:transition spd="med">
+        <p:fade/>
+      </p:transition>
+    </mc:Fallback>
+  </mc:AlternateContent>
 </p:sldLayout>
 </file>
 
@@ -564,10 +1669,9 @@
           <a:lstStyle/>
           <a:p>
             <a:r>
-              <a:rPr lang="en-US" smtClean="0"/>
+              <a:rPr lang="en-US"/>
               <a:t>Click to edit Master title style</a:t>
             </a:r>
-            <a:endParaRPr lang="en-US"/>
           </a:p>
         </p:txBody>
       </p:sp>
@@ -593,38 +1697,37 @@
           <a:p>
             <a:pPr lvl="0"/>
             <a:r>
-              <a:rPr lang="en-US" smtClean="0"/>
+              <a:rPr lang="en-US"/>
               <a:t>Click to edit Master text styles</a:t>
             </a:r>
           </a:p>
           <a:p>
             <a:pPr lvl="1"/>
             <a:r>
-              <a:rPr lang="en-US" smtClean="0"/>
+              <a:rPr lang="en-US"/>
               <a:t>Second level</a:t>
             </a:r>
           </a:p>
           <a:p>
             <a:pPr lvl="2"/>
             <a:r>
-              <a:rPr lang="en-US" smtClean="0"/>
+              <a:rPr lang="en-US"/>
               <a:t>Third level</a:t>
             </a:r>
           </a:p>
           <a:p>
             <a:pPr lvl="3"/>
             <a:r>
-              <a:rPr lang="en-US" smtClean="0"/>
+              <a:rPr lang="en-US"/>
               <a:t>Fourth level</a:t>
             </a:r>
           </a:p>
           <a:p>
             <a:pPr lvl="4"/>
             <a:r>
-              <a:rPr lang="en-US" smtClean="0"/>
+              <a:rPr lang="en-US"/>
               <a:t>Fifth level</a:t>
             </a:r>
-            <a:endParaRPr lang="en-US"/>
           </a:p>
         </p:txBody>
       </p:sp>
@@ -645,7 +1748,7 @@
           <a:p>
             <a:fld id="{5BCAD085-E8A6-8845-BD4E-CB4CCA059FC4}" type="datetimeFigureOut">
               <a:rPr lang="en-US" smtClean="0"/>
-              <a:t>1/27/13</a:t>
+              <a:t>10/27/2026</a:t>
             </a:fld>
             <a:endParaRPr lang="en-US"/>
           </a:p>
@@ -703,6 +1806,18 @@
   <p:clrMapOvr>
     <a:masterClrMapping/>
   </p:clrMapOvr>
+  <mc:AlternateContent xmlns:mc="http://schemas.openxmlformats.org/markup-compatibility/2006" xmlns:p14="http://schemas.microsoft.com/office/powerpoint/2010/main">
+    <mc:Choice Requires="p14">
+      <p:transition spd="med" p14:dur="700">
+        <p:fade/>
+      </p:transition>
+    </mc:Choice>
+    <mc:Fallback xmlns="">
+      <p:transition spd="med">
+        <p:fade/>
+      </p:transition>
+    </mc:Fallback>
+  </mc:AlternateContent>
 </p:sldLayout>
 </file>
 
@@ -739,10 +1854,9 @@
           <a:lstStyle/>
           <a:p>
             <a:r>
-              <a:rPr lang="en-US" smtClean="0"/>
+              <a:rPr lang="en-US"/>
               <a:t>Click to edit Master title style</a:t>
             </a:r>
-            <a:endParaRPr lang="en-US"/>
           </a:p>
         </p:txBody>
       </p:sp>
@@ -763,38 +1877,37 @@
           <a:p>
             <a:pPr lvl="0"/>
             <a:r>
-              <a:rPr lang="en-US" smtClean="0"/>
+              <a:rPr lang="en-US"/>
               <a:t>Click to edit Master text styles</a:t>
             </a:r>
           </a:p>
           <a:p>
             <a:pPr lvl="1"/>
             <a:r>
-              <a:rPr lang="en-US" smtClean="0"/>
+              <a:rPr lang="en-US"/>
               <a:t>Second level</a:t>
             </a:r>
           </a:p>
           <a:p>
             <a:pPr lvl="2"/>
             <a:r>
-              <a:rPr lang="en-US" smtClean="0"/>
+              <a:rPr lang="en-US"/>
               <a:t>Third level</a:t>
             </a:r>
           </a:p>
           <a:p>
             <a:pPr lvl="3"/>
             <a:r>
-              <a:rPr lang="en-US" smtClean="0"/>
+              <a:rPr lang="en-US"/>
               <a:t>Fourth level</a:t>
             </a:r>
           </a:p>
           <a:p>
             <a:pPr lvl="4"/>
             <a:r>
-              <a:rPr lang="en-US" smtClean="0"/>
+              <a:rPr lang="en-US"/>
               <a:t>Fifth level</a:t>
             </a:r>
-            <a:endParaRPr lang="en-US"/>
           </a:p>
         </p:txBody>
       </p:sp>
@@ -815,7 +1928,7 @@
           <a:p>
             <a:fld id="{5BCAD085-E8A6-8845-BD4E-CB4CCA059FC4}" type="datetimeFigureOut">
               <a:rPr lang="en-US" smtClean="0"/>
-              <a:t>1/27/13</a:t>
+              <a:t>10/27/2026</a:t>
             </a:fld>
             <a:endParaRPr lang="en-US"/>
           </a:p>
@@ -873,6 +1986,18 @@
   <p:clrMapOvr>
     <a:masterClrMapping/>
   </p:clrMapOvr>
+  <mc:AlternateContent xmlns:mc="http://schemas.openxmlformats.org/markup-compatibility/2006" xmlns:p14="http://schemas.microsoft.com/office/powerpoint/2010/main">
+    <mc:Choice Requires="p14">
+      <p:transition spd="med" p14:dur="700">
+        <p:fade/>
+      </p:transition>
+    </mc:Choice>
+    <mc:Fallback xmlns="">
+      <p:transition spd="med">
+        <p:fade/>
+      </p:transition>
+    </mc:Fallback>
+  </mc:AlternateContent>
 </p:sldLayout>
 </file>
 
@@ -918,10 +2043,9 @@
           </a:lstStyle>
           <a:p>
             <a:r>
-              <a:rPr lang="en-US" smtClean="0"/>
+              <a:rPr lang="en-US"/>
               <a:t>Click to edit Master title style</a:t>
             </a:r>
-            <a:endParaRPr lang="en-US"/>
           </a:p>
         </p:txBody>
       </p:sp>
@@ -1038,7 +2162,7 @@
           <a:p>
             <a:pPr lvl="0"/>
             <a:r>
-              <a:rPr lang="en-US" smtClean="0"/>
+              <a:rPr lang="en-US"/>
               <a:t>Click to edit Master text styles</a:t>
             </a:r>
           </a:p>
@@ -1061,7 +2185,7 @@
           <a:p>
             <a:fld id="{5BCAD085-E8A6-8845-BD4E-CB4CCA059FC4}" type="datetimeFigureOut">
               <a:rPr lang="en-US" smtClean="0"/>
-              <a:t>1/27/13</a:t>
+              <a:t>10/27/2026</a:t>
             </a:fld>
             <a:endParaRPr lang="en-US"/>
           </a:p>
@@ -1119,6 +2243,18 @@
   <p:clrMapOvr>
     <a:masterClrMapping/>
   </p:clrMapOvr>
+  <mc:AlternateContent xmlns:mc="http://schemas.openxmlformats.org/markup-compatibility/2006" xmlns:p14="http://schemas.microsoft.com/office/powerpoint/2010/main">
+    <mc:Choice Requires="p14">
+      <p:transition spd="med" p14:dur="700">
+        <p:fade/>
+      </p:transition>
+    </mc:Choice>
+    <mc:Fallback xmlns="">
+      <p:transition spd="med">
+        <p:fade/>
+      </p:transition>
+    </mc:Fallback>
+  </mc:AlternateContent>
 </p:sldLayout>
 </file>
 
@@ -1155,10 +2291,9 @@
           <a:lstStyle/>
           <a:p>
             <a:r>
-              <a:rPr lang="en-US" smtClean="0"/>
+              <a:rPr lang="en-US"/>
               <a:t>Click to edit Master title style</a:t>
             </a:r>
-            <a:endParaRPr lang="en-US"/>
           </a:p>
         </p:txBody>
       </p:sp>
@@ -1212,38 +2347,37 @@
           <a:p>
             <a:pPr lvl="0"/>
             <a:r>
-              <a:rPr lang="en-US" smtClean="0"/>
+              <a:rPr lang="en-US"/>
               <a:t>Click to edit Master text styles</a:t>
             </a:r>
           </a:p>
           <a:p>
             <a:pPr lvl="1"/>
             <a:r>
-              <a:rPr lang="en-US" smtClean="0"/>
+              <a:rPr lang="en-US"/>
               <a:t>Second level</a:t>
             </a:r>
           </a:p>
           <a:p>
             <a:pPr lvl="2"/>
             <a:r>
-              <a:rPr lang="en-US" smtClean="0"/>
+              <a:rPr lang="en-US"/>
               <a:t>Third level</a:t>
             </a:r>
           </a:p>
           <a:p>
             <a:pPr lvl="3"/>
             <a:r>
-              <a:rPr lang="en-US" smtClean="0"/>
+              <a:rPr lang="en-US"/>
               <a:t>Fourth level</a:t>
             </a:r>
           </a:p>
           <a:p>
             <a:pPr lvl="4"/>
             <a:r>
-              <a:rPr lang="en-US" smtClean="0"/>
+              <a:rPr lang="en-US"/>
               <a:t>Fifth level</a:t>
             </a:r>
-            <a:endParaRPr lang="en-US"/>
           </a:p>
         </p:txBody>
       </p:sp>
@@ -1297,38 +2431,37 @@
           <a:p>
             <a:pPr lvl="0"/>
             <a:r>
-              <a:rPr lang="en-US" smtClean="0"/>
+              <a:rPr lang="en-US"/>
               <a:t>Click to edit Master text styles</a:t>
             </a:r>
           </a:p>
           <a:p>
             <a:pPr lvl="1"/>
             <a:r>
-              <a:rPr lang="en-US" smtClean="0"/>
+              <a:rPr lang="en-US"/>
               <a:t>Second level</a:t>
             </a:r>
           </a:p>
           <a:p>
             <a:pPr lvl="2"/>
             <a:r>
-              <a:rPr lang="en-US" smtClean="0"/>
+              <a:rPr lang="en-US"/>
               <a:t>Third level</a:t>
             </a:r>
           </a:p>
           <a:p>
             <a:pPr lvl="3"/>
             <a:r>
-              <a:rPr lang="en-US" smtClean="0"/>
+              <a:rPr lang="en-US"/>
               <a:t>Fourth level</a:t>
             </a:r>
           </a:p>
           <a:p>
             <a:pPr lvl="4"/>
             <a:r>
-              <a:rPr lang="en-US" smtClean="0"/>
+              <a:rPr lang="en-US"/>
               <a:t>Fifth level</a:t>
             </a:r>
-            <a:endParaRPr lang="en-US"/>
           </a:p>
         </p:txBody>
       </p:sp>
@@ -1349,7 +2482,7 @@
           <a:p>
             <a:fld id="{5BCAD085-E8A6-8845-BD4E-CB4CCA059FC4}" type="datetimeFigureOut">
               <a:rPr lang="en-US" smtClean="0"/>
-              <a:t>1/27/13</a:t>
+              <a:t>10/27/2026</a:t>
             </a:fld>
             <a:endParaRPr lang="en-US"/>
           </a:p>
@@ -1407,6 +2540,18 @@
   <p:clrMapOvr>
     <a:masterClrMapping/>
   </p:clrMapOvr>
+  <mc:AlternateContent xmlns:mc="http://schemas.openxmlformats.org/markup-compatibility/2006" xmlns:p14="http://schemas.microsoft.com/office/powerpoint/2010/main">
+    <mc:Choice Requires="p14">
+      <p:transition spd="med" p14:dur="700">
+        <p:fade/>
+      </p:transition>
+    </mc:Choice>
+    <mc:Fallback xmlns="">
+      <p:transition spd="med">
+        <p:fade/>
+      </p:transition>
+    </mc:Fallback>
+  </mc:AlternateContent>
 </p:sldLayout>
 </file>
 
@@ -1447,10 +2592,9 @@
           </a:lstStyle>
           <a:p>
             <a:r>
-              <a:rPr lang="en-US" smtClean="0"/>
+              <a:rPr lang="en-US"/>
               <a:t>Click to edit Master title style</a:t>
             </a:r>
-            <a:endParaRPr lang="en-US"/>
           </a:p>
         </p:txBody>
       </p:sp>
@@ -1513,7 +2657,7 @@
           <a:p>
             <a:pPr lvl="0"/>
             <a:r>
-              <a:rPr lang="en-US" smtClean="0"/>
+              <a:rPr lang="en-US"/>
               <a:t>Click to edit Master text styles</a:t>
             </a:r>
           </a:p>
@@ -1569,38 +2713,37 @@
           <a:p>
             <a:pPr lvl="0"/>
             <a:r>
-              <a:rPr lang="en-US" smtClean="0"/>
+              <a:rPr lang="en-US"/>
               <a:t>Click to edit Master text styles</a:t>
             </a:r>
           </a:p>
           <a:p>
             <a:pPr lvl="1"/>
             <a:r>
-              <a:rPr lang="en-US" smtClean="0"/>
+              <a:rPr lang="en-US"/>
               <a:t>Second level</a:t>
             </a:r>
           </a:p>
           <a:p>
             <a:pPr lvl="2"/>
             <a:r>
-              <a:rPr lang="en-US" smtClean="0"/>
+              <a:rPr lang="en-US"/>
               <a:t>Third level</a:t>
             </a:r>
           </a:p>
           <a:p>
             <a:pPr lvl="3"/>
             <a:r>
-              <a:rPr lang="en-US" smtClean="0"/>
+              <a:rPr lang="en-US"/>
               <a:t>Fourth level</a:t>
             </a:r>
           </a:p>
           <a:p>
             <a:pPr lvl="4"/>
             <a:r>
-              <a:rPr lang="en-US" smtClean="0"/>
+              <a:rPr lang="en-US"/>
               <a:t>Fifth level</a:t>
             </a:r>
-            <a:endParaRPr lang="en-US"/>
           </a:p>
         </p:txBody>
       </p:sp>
@@ -1663,7 +2806,7 @@
           <a:p>
             <a:pPr lvl="0"/>
             <a:r>
-              <a:rPr lang="en-US" smtClean="0"/>
+              <a:rPr lang="en-US"/>
               <a:t>Click to edit Master text styles</a:t>
             </a:r>
           </a:p>
@@ -1719,38 +2862,37 @@
           <a:p>
             <a:pPr lvl="0"/>
             <a:r>
-              <a:rPr lang="en-US" smtClean="0"/>
+              <a:rPr lang="en-US"/>
               <a:t>Click to edit Master text styles</a:t>
             </a:r>
           </a:p>
           <a:p>
             <a:pPr lvl="1"/>
             <a:r>
-              <a:rPr lang="en-US" smtClean="0"/>
+              <a:rPr lang="en-US"/>
               <a:t>Second level</a:t>
             </a:r>
           </a:p>
           <a:p>
             <a:pPr lvl="2"/>
             <a:r>
-              <a:rPr lang="en-US" smtClean="0"/>
+              <a:rPr lang="en-US"/>
               <a:t>Third level</a:t>
             </a:r>
           </a:p>
           <a:p>
             <a:pPr lvl="3"/>
             <a:r>
-              <a:rPr lang="en-US" smtClean="0"/>
+              <a:rPr lang="en-US"/>
               <a:t>Fourth level</a:t>
             </a:r>
           </a:p>
           <a:p>
             <a:pPr lvl="4"/>
             <a:r>
-              <a:rPr lang="en-US" smtClean="0"/>
+              <a:rPr lang="en-US"/>
               <a:t>Fifth level</a:t>
             </a:r>
-            <a:endParaRPr lang="en-US"/>
           </a:p>
         </p:txBody>
       </p:sp>
@@ -1771,7 +2913,7 @@
           <a:p>
             <a:fld id="{5BCAD085-E8A6-8845-BD4E-CB4CCA059FC4}" type="datetimeFigureOut">
               <a:rPr lang="en-US" smtClean="0"/>
-              <a:t>1/27/13</a:t>
+              <a:t>10/27/2026</a:t>
             </a:fld>
             <a:endParaRPr lang="en-US"/>
           </a:p>
@@ -1829,6 +2971,18 @@
   <p:clrMapOvr>
     <a:masterClrMapping/>
   </p:clrMapOvr>
+  <mc:AlternateContent xmlns:mc="http://schemas.openxmlformats.org/markup-compatibility/2006" xmlns:p14="http://schemas.microsoft.com/office/powerpoint/2010/main">
+    <mc:Choice Requires="p14">
+      <p:transition spd="med" p14:dur="700">
+        <p:fade/>
+      </p:transition>
+    </mc:Choice>
+    <mc:Fallback xmlns="">
+      <p:transition spd="med">
+        <p:fade/>
+      </p:transition>
+    </mc:Fallback>
+  </mc:AlternateContent>
 </p:sldLayout>
 </file>
 
@@ -1865,10 +3019,9 @@
           <a:lstStyle/>
           <a:p>
             <a:r>
-              <a:rPr lang="en-US" smtClean="0"/>
+              <a:rPr lang="en-US"/>
               <a:t>Click to edit Master title style</a:t>
             </a:r>
-            <a:endParaRPr lang="en-US"/>
           </a:p>
         </p:txBody>
       </p:sp>
@@ -1889,7 +3042,7 @@
           <a:p>
             <a:fld id="{5BCAD085-E8A6-8845-BD4E-CB4CCA059FC4}" type="datetimeFigureOut">
               <a:rPr lang="en-US" smtClean="0"/>
-              <a:t>1/27/13</a:t>
+              <a:t>10/27/2026</a:t>
             </a:fld>
             <a:endParaRPr lang="en-US"/>
           </a:p>
@@ -1947,6 +3100,18 @@
   <p:clrMapOvr>
     <a:masterClrMapping/>
   </p:clrMapOvr>
+  <mc:AlternateContent xmlns:mc="http://schemas.openxmlformats.org/markup-compatibility/2006" xmlns:p14="http://schemas.microsoft.com/office/powerpoint/2010/main">
+    <mc:Choice Requires="p14">
+      <p:transition spd="med" p14:dur="700">
+        <p:fade/>
+      </p:transition>
+    </mc:Choice>
+    <mc:Fallback xmlns="">
+      <p:transition spd="med">
+        <p:fade/>
+      </p:transition>
+    </mc:Fallback>
+  </mc:AlternateContent>
 </p:sldLayout>
 </file>
 
@@ -1984,7 +3149,7 @@
           <a:p>
             <a:fld id="{5BCAD085-E8A6-8845-BD4E-CB4CCA059FC4}" type="datetimeFigureOut">
               <a:rPr lang="en-US" smtClean="0"/>
-              <a:t>1/27/13</a:t>
+              <a:t>10/27/2026</a:t>
             </a:fld>
             <a:endParaRPr lang="en-US"/>
           </a:p>
@@ -2042,6 +3207,18 @@
   <p:clrMapOvr>
     <a:masterClrMapping/>
   </p:clrMapOvr>
+  <mc:AlternateContent xmlns:mc="http://schemas.openxmlformats.org/markup-compatibility/2006" xmlns:p14="http://schemas.microsoft.com/office/powerpoint/2010/main">
+    <mc:Choice Requires="p14">
+      <p:transition spd="med" p14:dur="700">
+        <p:fade/>
+      </p:transition>
+    </mc:Choice>
+    <mc:Fallback xmlns="">
+      <p:transition spd="med">
+        <p:fade/>
+      </p:transition>
+    </mc:Fallback>
+  </mc:AlternateContent>
 </p:sldLayout>
 </file>
 
@@ -2087,10 +3264,9 @@
           </a:lstStyle>
           <a:p>
             <a:r>
-              <a:rPr lang="en-US" smtClean="0"/>
+              <a:rPr lang="en-US"/>
               <a:t>Click to edit Master title style</a:t>
             </a:r>
-            <a:endParaRPr lang="en-US"/>
           </a:p>
         </p:txBody>
       </p:sp>
@@ -2144,38 +3320,37 @@
           <a:p>
             <a:pPr lvl="0"/>
             <a:r>
-              <a:rPr lang="en-US" smtClean="0"/>
+              <a:rPr lang="en-US"/>
               <a:t>Click to edit Master text styles</a:t>
             </a:r>
           </a:p>
           <a:p>
             <a:pPr lvl="1"/>
             <a:r>
-              <a:rPr lang="en-US" smtClean="0"/>
+              <a:rPr lang="en-US"/>
               <a:t>Second level</a:t>
             </a:r>
           </a:p>
           <a:p>
             <a:pPr lvl="2"/>
             <a:r>
-              <a:rPr lang="en-US" smtClean="0"/>
+              <a:rPr lang="en-US"/>
               <a:t>Third level</a:t>
             </a:r>
           </a:p>
           <a:p>
             <a:pPr lvl="3"/>
             <a:r>
-              <a:rPr lang="en-US" smtClean="0"/>
+              <a:rPr lang="en-US"/>
               <a:t>Fourth level</a:t>
             </a:r>
           </a:p>
           <a:p>
             <a:pPr lvl="4"/>
             <a:r>
-              <a:rPr lang="en-US" smtClean="0"/>
+              <a:rPr lang="en-US"/>
               <a:t>Fifth level</a:t>
             </a:r>
-            <a:endParaRPr lang="en-US"/>
           </a:p>
         </p:txBody>
       </p:sp>
@@ -2238,7 +3413,7 @@
           <a:p>
             <a:pPr lvl="0"/>
             <a:r>
-              <a:rPr lang="en-US" smtClean="0"/>
+              <a:rPr lang="en-US"/>
               <a:t>Click to edit Master text styles</a:t>
             </a:r>
           </a:p>
@@ -2261,7 +3436,7 @@
           <a:p>
             <a:fld id="{5BCAD085-E8A6-8845-BD4E-CB4CCA059FC4}" type="datetimeFigureOut">
               <a:rPr lang="en-US" smtClean="0"/>
-              <a:t>1/27/13</a:t>
+              <a:t>10/27/2026</a:t>
             </a:fld>
             <a:endParaRPr lang="en-US"/>
           </a:p>
@@ -2319,6 +3494,18 @@
   <p:clrMapOvr>
     <a:masterClrMapping/>
   </p:clrMapOvr>
+  <mc:AlternateContent xmlns:mc="http://schemas.openxmlformats.org/markup-compatibility/2006" xmlns:p14="http://schemas.microsoft.com/office/powerpoint/2010/main">
+    <mc:Choice Requires="p14">
+      <p:transition spd="med" p14:dur="700">
+        <p:fade/>
+      </p:transition>
+    </mc:Choice>
+    <mc:Fallback xmlns="">
+      <p:transition spd="med">
+        <p:fade/>
+      </p:transition>
+    </mc:Fallback>
+  </mc:AlternateContent>
 </p:sldLayout>
 </file>
 
@@ -2364,10 +3551,9 @@
           </a:lstStyle>
           <a:p>
             <a:r>
-              <a:rPr lang="en-US" smtClean="0"/>
+              <a:rPr lang="en-US"/>
               <a:t>Click to edit Master title style</a:t>
             </a:r>
-            <a:endParaRPr lang="en-US"/>
           </a:p>
         </p:txBody>
       </p:sp>
@@ -2491,7 +3677,7 @@
           <a:p>
             <a:pPr lvl="0"/>
             <a:r>
-              <a:rPr lang="en-US" smtClean="0"/>
+              <a:rPr lang="en-US"/>
               <a:t>Click to edit Master text styles</a:t>
             </a:r>
           </a:p>
@@ -2514,7 +3700,7 @@
           <a:p>
             <a:fld id="{5BCAD085-E8A6-8845-BD4E-CB4CCA059FC4}" type="datetimeFigureOut">
               <a:rPr lang="en-US" smtClean="0"/>
-              <a:t>1/27/13</a:t>
+              <a:t>10/27/2026</a:t>
             </a:fld>
             <a:endParaRPr lang="en-US"/>
           </a:p>
@@ -2572,6 +3758,18 @@
   <p:clrMapOvr>
     <a:masterClrMapping/>
   </p:clrMapOvr>
+  <mc:AlternateContent xmlns:mc="http://schemas.openxmlformats.org/markup-compatibility/2006" xmlns:p14="http://schemas.microsoft.com/office/powerpoint/2010/main">
+    <mc:Choice Requires="p14">
+      <p:transition spd="med" p14:dur="700">
+        <p:fade/>
+      </p:transition>
+    </mc:Choice>
+    <mc:Fallback xmlns="">
+      <p:transition spd="med">
+        <p:fade/>
+      </p:transition>
+    </mc:Fallback>
+  </mc:AlternateContent>
 </p:sldLayout>
 </file>
 
@@ -2623,10 +3821,9 @@
           <a:lstStyle/>
           <a:p>
             <a:r>
-              <a:rPr lang="en-US" smtClean="0"/>
+              <a:rPr lang="en-US"/>
               <a:t>Click to edit Master title style</a:t>
             </a:r>
-            <a:endParaRPr lang="en-US"/>
           </a:p>
         </p:txBody>
       </p:sp>
@@ -2657,38 +3854,37 @@
           <a:p>
             <a:pPr lvl="0"/>
             <a:r>
-              <a:rPr lang="en-US" smtClean="0"/>
+              <a:rPr lang="en-US"/>
               <a:t>Click to edit Master text styles</a:t>
             </a:r>
           </a:p>
           <a:p>
             <a:pPr lvl="1"/>
             <a:r>
-              <a:rPr lang="en-US" smtClean="0"/>
+              <a:rPr lang="en-US"/>
               <a:t>Second level</a:t>
             </a:r>
           </a:p>
           <a:p>
             <a:pPr lvl="2"/>
             <a:r>
-              <a:rPr lang="en-US" smtClean="0"/>
+              <a:rPr lang="en-US"/>
               <a:t>Third level</a:t>
             </a:r>
           </a:p>
           <a:p>
             <a:pPr lvl="3"/>
             <a:r>
-              <a:rPr lang="en-US" smtClean="0"/>
+              <a:rPr lang="en-US"/>
               <a:t>Fourth level</a:t>
             </a:r>
           </a:p>
           <a:p>
             <a:pPr lvl="4"/>
             <a:r>
-              <a:rPr lang="en-US" smtClean="0"/>
+              <a:rPr lang="en-US"/>
               <a:t>Fifth level</a:t>
             </a:r>
-            <a:endParaRPr lang="en-US"/>
           </a:p>
         </p:txBody>
       </p:sp>
@@ -2727,7 +3923,7 @@
           <a:p>
             <a:fld id="{5BCAD085-E8A6-8845-BD4E-CB4CCA059FC4}" type="datetimeFigureOut">
               <a:rPr lang="en-US" smtClean="0"/>
-              <a:t>1/27/13</a:t>
+              <a:t>10/27/2026</a:t>
             </a:fld>
             <a:endParaRPr lang="en-US"/>
           </a:p>
@@ -2832,6 +4028,18 @@
     <p:sldLayoutId id="2147483658" r:id="rId10"/>
     <p:sldLayoutId id="2147483659" r:id="rId11"/>
   </p:sldLayoutIdLst>
+  <mc:AlternateContent xmlns:mc="http://schemas.openxmlformats.org/markup-compatibility/2006" xmlns:p14="http://schemas.microsoft.com/office/powerpoint/2010/main">
+    <mc:Choice Requires="p14">
+      <p:transition spd="med" p14:dur="700">
+        <p:fade/>
+      </p:transition>
+    </mc:Choice>
+    <mc:Fallback xmlns="">
+      <p:transition spd="med">
+        <p:fade/>
+      </p:transition>
+    </mc:Fallback>
+  </mc:AlternateContent>
   <p:txStyles>
     <p:titleStyle>
       <a:lvl1pPr algn="ctr" defTabSz="457200" rtl="0" eaLnBrk="1" latinLnBrk="0" hangingPunct="1">
@@ -3086,7 +4294,7 @@
 </file>
 
 <file path=ppt/slides/slide1.xml><?xml version="1.0" encoding="utf-8"?>
-<p:sld xmlns:a="http://schemas.openxmlformats.org/drawingml/2006/main" xmlns:p="http://schemas.openxmlformats.org/presentationml/2006/main" xmlns:r="http://schemas.openxmlformats.org/officeDocument/2006/relationships">
+<p:sld xmlns:a="http://schemas.openxmlformats.org/drawingml/2006/main" xmlns:r="http://schemas.openxmlformats.org/officeDocument/2006/relationships" xmlns:p="http://schemas.openxmlformats.org/presentationml/2006/main">
   <p:cSld>
     <p:bg>
       <p:bgPr>
@@ -3102,7 +4310,14 @@
         <p:cNvGrpSpPr/>
         <p:nvPr/>
       </p:nvGrpSpPr>
-      <p:grpSpPr/>
+      <p:grpSpPr>
+        <a:xfrm>
+          <a:off x="0" y="0"/>
+          <a:ext cx="0" cy="0"/>
+          <a:chOff x="0" y="0"/>
+          <a:chExt cx="0" cy="0"/>
+        </a:xfrm>
+      </p:grpSpPr>
       <p:sp>
         <p:nvSpPr>
           <p:cNvPr id="2" name="Oval 1"/>
@@ -3143,6 +4358,7 @@
           <a:lstStyle/>
           <a:p>
             <a:pPr algn="ctr"/>
+            <a:endParaRPr/>
           </a:p>
         </p:txBody>
       </p:sp>
@@ -3186,6 +4402,7 @@
           <a:lstStyle/>
           <a:p>
             <a:pPr algn="ctr"/>
+            <a:endParaRPr/>
           </a:p>
         </p:txBody>
       </p:sp>
@@ -3229,6 +4446,7 @@
           <a:lstStyle/>
           <a:p>
             <a:pPr algn="ctr"/>
+            <a:endParaRPr/>
           </a:p>
         </p:txBody>
       </p:sp>
@@ -3249,7 +4467,7 @@
           <a:noFill/>
         </p:spPr>
         <p:txBody>
-          <a:bodyPr wrap="square" lIns="36576" rIns="36576" tIns="36576" bIns="36576" anchor="t">
+          <a:bodyPr wrap="square" lIns="36576" tIns="36576" rIns="36576" bIns="36576" anchor="t">
             <a:spAutoFit/>
           </a:bodyPr>
           <a:lstStyle/>
@@ -3288,7 +4506,7 @@
           <a:noFill/>
         </p:spPr>
         <p:txBody>
-          <a:bodyPr wrap="square" lIns="36576" rIns="36576" tIns="36576" bIns="36576" anchor="t">
+          <a:bodyPr wrap="square" lIns="36576" tIns="36576" rIns="36576" bIns="36576" anchor="t">
             <a:spAutoFit/>
           </a:bodyPr>
           <a:lstStyle/>
@@ -3343,7 +4561,7 @@
           <a:noFill/>
         </p:spPr>
         <p:txBody>
-          <a:bodyPr wrap="square" lIns="36576" rIns="36576" tIns="36576" bIns="36576" anchor="t">
+          <a:bodyPr wrap="square" lIns="36576" tIns="36576" rIns="36576" bIns="36576" anchor="t">
             <a:spAutoFit/>
           </a:bodyPr>
           <a:lstStyle/>
@@ -3360,6 +4578,7 @@
               </a:defRPr>
             </a:pPr>
             <a:r>
+              <a:rPr dirty="0"/>
               <a:t>Modernizing the customer experience while reusing the existing e-commerce backend</a:t>
             </a:r>
           </a:p>
@@ -3382,7 +4601,7 @@
           <a:noFill/>
         </p:spPr>
         <p:txBody>
-          <a:bodyPr wrap="square" lIns="36576" rIns="36576" tIns="36576" bIns="36576" anchor="t">
+          <a:bodyPr wrap="square" lIns="36576" tIns="36576" rIns="36576" bIns="36576" anchor="t">
             <a:spAutoFit/>
           </a:bodyPr>
           <a:lstStyle/>
@@ -3421,7 +4640,7 @@
           <a:noFill/>
         </p:spPr>
         <p:txBody>
-          <a:bodyPr wrap="square" lIns="36576" rIns="36576" tIns="36576" bIns="36576" anchor="t">
+          <a:bodyPr wrap="square" lIns="36576" tIns="36576" rIns="36576" bIns="36576" anchor="t">
             <a:spAutoFit/>
           </a:bodyPr>
           <a:lstStyle/>
@@ -3448,11 +4667,23 @@
   <p:clrMapOvr>
     <a:masterClrMapping/>
   </p:clrMapOvr>
+  <mc:AlternateContent xmlns:mc="http://schemas.openxmlformats.org/markup-compatibility/2006" xmlns:p14="http://schemas.microsoft.com/office/powerpoint/2010/main">
+    <mc:Choice Requires="p14">
+      <p:transition spd="med" p14:dur="700">
+        <p:fade/>
+      </p:transition>
+    </mc:Choice>
+    <mc:Fallback xmlns="">
+      <p:transition spd="med">
+        <p:fade/>
+      </p:transition>
+    </mc:Fallback>
+  </mc:AlternateContent>
 </p:sld>
 </file>
 
 <file path=ppt/slides/slide2.xml><?xml version="1.0" encoding="utf-8"?>
-<p:sld xmlns:a="http://schemas.openxmlformats.org/drawingml/2006/main" xmlns:p="http://schemas.openxmlformats.org/presentationml/2006/main" xmlns:r="http://schemas.openxmlformats.org/officeDocument/2006/relationships">
+<p:sld xmlns:a="http://schemas.openxmlformats.org/drawingml/2006/main" xmlns:r="http://schemas.openxmlformats.org/officeDocument/2006/relationships" xmlns:p="http://schemas.openxmlformats.org/presentationml/2006/main">
   <p:cSld>
     <p:bg>
       <p:bgPr>
@@ -3468,7 +4699,14 @@
         <p:cNvGrpSpPr/>
         <p:nvPr/>
       </p:nvGrpSpPr>
-      <p:grpSpPr/>
+      <p:grpSpPr>
+        <a:xfrm>
+          <a:off x="0" y="0"/>
+          <a:ext cx="0" cy="0"/>
+          <a:chOff x="0" y="0"/>
+          <a:chExt cx="0" cy="0"/>
+        </a:xfrm>
+      </p:grpSpPr>
       <p:sp>
         <p:nvSpPr>
           <p:cNvPr id="2" name="TextBox 1"/>
@@ -3486,7 +4724,7 @@
           <a:noFill/>
         </p:spPr>
         <p:txBody>
-          <a:bodyPr wrap="square" lIns="36576" rIns="36576" tIns="36576" bIns="36576" anchor="t">
+          <a:bodyPr wrap="square" lIns="36576" tIns="36576" rIns="36576" bIns="36576" anchor="t">
             <a:spAutoFit/>
           </a:bodyPr>
           <a:lstStyle/>
@@ -3525,7 +4763,7 @@
           <a:noFill/>
         </p:spPr>
         <p:txBody>
-          <a:bodyPr wrap="square" lIns="36576" rIns="36576" tIns="36576" bIns="36576" anchor="t">
+          <a:bodyPr wrap="square" lIns="36576" tIns="36576" rIns="36576" bIns="36576" anchor="t">
             <a:spAutoFit/>
           </a:bodyPr>
           <a:lstStyle/>
@@ -3587,6 +4825,7 @@
           <a:lstStyle/>
           <a:p>
             <a:pPr algn="ctr"/>
+            <a:endParaRPr/>
           </a:p>
         </p:txBody>
       </p:sp>
@@ -3607,7 +4846,7 @@
           <a:noFill/>
         </p:spPr>
         <p:txBody>
-          <a:bodyPr wrap="square" lIns="36576" rIns="36576" tIns="36576" bIns="36576" anchor="t">
+          <a:bodyPr wrap="square" lIns="36576" tIns="36576" rIns="36576" bIns="36576" anchor="t">
             <a:spAutoFit/>
           </a:bodyPr>
           <a:lstStyle/>
@@ -3646,7 +4885,7 @@
           <a:noFill/>
         </p:spPr>
         <p:txBody>
-          <a:bodyPr wrap="square" lIns="36576" rIns="36576" tIns="36576" bIns="36576" anchor="t">
+          <a:bodyPr wrap="square" lIns="36576" tIns="36576" rIns="36576" bIns="36576" anchor="t">
             <a:spAutoFit/>
           </a:bodyPr>
           <a:lstStyle/>
@@ -3710,6 +4949,7 @@
           <a:lstStyle/>
           <a:p>
             <a:pPr algn="ctr"/>
+            <a:endParaRPr/>
           </a:p>
         </p:txBody>
       </p:sp>
@@ -3753,6 +4993,7 @@
           <a:lstStyle/>
           <a:p>
             <a:pPr algn="ctr"/>
+            <a:endParaRPr/>
           </a:p>
         </p:txBody>
       </p:sp>
@@ -3773,7 +5014,7 @@
           <a:noFill/>
         </p:spPr>
         <p:txBody>
-          <a:bodyPr wrap="square" lIns="36576" rIns="36576" tIns="36576" bIns="36576" anchor="t">
+          <a:bodyPr wrap="square" lIns="36576" tIns="36576" rIns="36576" bIns="36576" anchor="t">
             <a:spAutoFit/>
           </a:bodyPr>
           <a:lstStyle/>
@@ -3812,7 +5053,7 @@
           <a:noFill/>
         </p:spPr>
         <p:txBody>
-          <a:bodyPr wrap="square" lIns="36576" rIns="36576" tIns="36576" bIns="36576" anchor="t">
+          <a:bodyPr wrap="square" lIns="36576" tIns="36576" rIns="36576" bIns="36576" anchor="t">
             <a:spAutoFit/>
           </a:bodyPr>
           <a:lstStyle/>
@@ -3876,6 +5117,7 @@
           <a:lstStyle/>
           <a:p>
             <a:pPr algn="ctr"/>
+            <a:endParaRPr/>
           </a:p>
         </p:txBody>
       </p:sp>
@@ -3919,6 +5161,7 @@
           <a:lstStyle/>
           <a:p>
             <a:pPr algn="ctr"/>
+            <a:endParaRPr/>
           </a:p>
         </p:txBody>
       </p:sp>
@@ -3939,7 +5182,7 @@
           <a:noFill/>
         </p:spPr>
         <p:txBody>
-          <a:bodyPr wrap="square" lIns="36576" rIns="36576" tIns="36576" bIns="36576" anchor="t">
+          <a:bodyPr wrap="square" lIns="36576" tIns="36576" rIns="36576" bIns="36576" anchor="t">
             <a:spAutoFit/>
           </a:bodyPr>
           <a:lstStyle/>
@@ -3978,7 +5221,7 @@
           <a:noFill/>
         </p:spPr>
         <p:txBody>
-          <a:bodyPr wrap="square" lIns="36576" rIns="36576" tIns="36576" bIns="36576" anchor="t">
+          <a:bodyPr wrap="square" lIns="36576" tIns="36576" rIns="36576" bIns="36576" anchor="t">
             <a:spAutoFit/>
           </a:bodyPr>
           <a:lstStyle/>
@@ -4042,6 +5285,7 @@
           <a:lstStyle/>
           <a:p>
             <a:pPr algn="ctr"/>
+            <a:endParaRPr/>
           </a:p>
         </p:txBody>
       </p:sp>
@@ -4085,6 +5329,7 @@
           <a:lstStyle/>
           <a:p>
             <a:pPr algn="ctr"/>
+            <a:endParaRPr/>
           </a:p>
         </p:txBody>
       </p:sp>
@@ -4105,7 +5350,7 @@
           <a:noFill/>
         </p:spPr>
         <p:txBody>
-          <a:bodyPr wrap="square" lIns="36576" rIns="36576" tIns="36576" bIns="36576" anchor="t">
+          <a:bodyPr wrap="square" lIns="36576" tIns="36576" rIns="36576" bIns="36576" anchor="t">
             <a:spAutoFit/>
           </a:bodyPr>
           <a:lstStyle/>
@@ -4144,7 +5389,7 @@
           <a:noFill/>
         </p:spPr>
         <p:txBody>
-          <a:bodyPr wrap="square" lIns="36576" rIns="36576" tIns="36576" bIns="36576" anchor="t">
+          <a:bodyPr wrap="square" lIns="36576" tIns="36576" rIns="36576" bIns="36576" anchor="t">
             <a:spAutoFit/>
           </a:bodyPr>
           <a:lstStyle/>
@@ -4183,7 +5428,7 @@
           <a:noFill/>
         </p:spPr>
         <p:txBody>
-          <a:bodyPr wrap="square" lIns="36576" rIns="36576" tIns="36576" bIns="36576" anchor="t">
+          <a:bodyPr wrap="square" lIns="36576" tIns="36576" rIns="36576" bIns="36576" anchor="t">
             <a:spAutoFit/>
           </a:bodyPr>
           <a:lstStyle/>
@@ -4222,7 +5467,7 @@
           <a:noFill/>
         </p:spPr>
         <p:txBody>
-          <a:bodyPr wrap="square" lIns="36576" rIns="36576" tIns="36576" bIns="36576" anchor="t">
+          <a:bodyPr wrap="square" lIns="36576" tIns="36576" rIns="36576" bIns="36576" anchor="t">
             <a:spAutoFit/>
           </a:bodyPr>
           <a:lstStyle/>
@@ -4244,55 +5489,28 @@
           </a:p>
         </p:txBody>
       </p:sp>
-      <p:sp>
-        <p:nvSpPr>
-          <p:cNvPr id="21" name="TextBox 20"/>
-          <p:cNvSpPr txBox="1"/>
-          <p:nvPr/>
-        </p:nvSpPr>
-        <p:spPr>
-          <a:xfrm>
-            <a:off x="896112" y="5577840"/>
-            <a:ext cx="10332720" cy="320040"/>
-          </a:xfrm>
-          <a:prstGeom prst="rect">
-            <a:avLst/>
-          </a:prstGeom>
-          <a:noFill/>
-        </p:spPr>
-        <p:txBody>
-          <a:bodyPr wrap="square" lIns="36576" rIns="36576" tIns="36576" bIns="36576" anchor="t">
-            <a:spAutoFit/>
-          </a:bodyPr>
-          <a:lstStyle/>
-          <a:p>
-            <a:pPr algn="l">
-              <a:spcAft>
-                <a:spcPts val="500"/>
-              </a:spcAft>
-              <a:defRPr sz="1000" b="0">
-                <a:solidFill>
-                  <a:srgbClr val="9DB1CA"/>
-                </a:solidFill>
-                <a:latin typeface="Aptos"/>
-              </a:defRPr>
-            </a:pPr>
-            <a:r>
-              <a:t>Note: the supplied screenshots show location/QR access, menu, cart, and profile. Login screenshots were not identifiable in this upload set.</a:t>
-            </a:r>
-          </a:p>
-        </p:txBody>
-      </p:sp>
     </p:spTree>
   </p:cSld>
   <p:clrMapOvr>
     <a:masterClrMapping/>
   </p:clrMapOvr>
+  <mc:AlternateContent xmlns:mc="http://schemas.openxmlformats.org/markup-compatibility/2006" xmlns:p14="http://schemas.microsoft.com/office/powerpoint/2010/main">
+    <mc:Choice Requires="p14">
+      <p:transition spd="med" p14:dur="700">
+        <p:fade/>
+      </p:transition>
+    </mc:Choice>
+    <mc:Fallback xmlns="">
+      <p:transition spd="med">
+        <p:fade/>
+      </p:transition>
+    </mc:Fallback>
+  </mc:AlternateContent>
 </p:sld>
 </file>
 
 <file path=ppt/slides/slide3.xml><?xml version="1.0" encoding="utf-8"?>
-<p:sld xmlns:a="http://schemas.openxmlformats.org/drawingml/2006/main" xmlns:p="http://schemas.openxmlformats.org/presentationml/2006/main" xmlns:r="http://schemas.openxmlformats.org/officeDocument/2006/relationships">
+<p:sld xmlns:a="http://schemas.openxmlformats.org/drawingml/2006/main" xmlns:r="http://schemas.openxmlformats.org/officeDocument/2006/relationships" xmlns:p="http://schemas.openxmlformats.org/presentationml/2006/main">
   <p:cSld>
     <p:bg>
       <p:bgPr>
@@ -4308,7 +5526,14 @@
         <p:cNvGrpSpPr/>
         <p:nvPr/>
       </p:nvGrpSpPr>
-      <p:grpSpPr/>
+      <p:grpSpPr>
+        <a:xfrm>
+          <a:off x="0" y="0"/>
+          <a:ext cx="0" cy="0"/>
+          <a:chOff x="0" y="0"/>
+          <a:chExt cx="0" cy="0"/>
+        </a:xfrm>
+      </p:grpSpPr>
       <p:sp>
         <p:nvSpPr>
           <p:cNvPr id="2" name="TextBox 1"/>
@@ -4326,7 +5551,7 @@
           <a:noFill/>
         </p:spPr>
         <p:txBody>
-          <a:bodyPr wrap="square" lIns="36576" rIns="36576" tIns="36576" bIns="36576" anchor="t">
+          <a:bodyPr wrap="square" lIns="36576" tIns="36576" rIns="36576" bIns="36576" anchor="t">
             <a:spAutoFit/>
           </a:bodyPr>
           <a:lstStyle/>
@@ -4365,7 +5590,7 @@
           <a:noFill/>
         </p:spPr>
         <p:txBody>
-          <a:bodyPr wrap="square" lIns="36576" rIns="36576" tIns="36576" bIns="36576" anchor="t">
+          <a:bodyPr wrap="square" lIns="36576" tIns="36576" rIns="36576" bIns="36576" anchor="t">
             <a:spAutoFit/>
           </a:bodyPr>
           <a:lstStyle/>
@@ -4427,6 +5652,7 @@
           <a:lstStyle/>
           <a:p>
             <a:pPr algn="ctr"/>
+            <a:endParaRPr/>
           </a:p>
         </p:txBody>
       </p:sp>
@@ -4447,7 +5673,7 @@
           <a:noFill/>
         </p:spPr>
         <p:txBody>
-          <a:bodyPr wrap="square" lIns="36576" rIns="36576" tIns="36576" bIns="36576" anchor="t">
+          <a:bodyPr wrap="square" lIns="36576" tIns="36576" rIns="36576" bIns="36576" anchor="t">
             <a:spAutoFit/>
           </a:bodyPr>
           <a:lstStyle/>
@@ -4486,7 +5712,7 @@
           <a:noFill/>
         </p:spPr>
         <p:txBody>
-          <a:bodyPr wrap="square" lIns="36576" rIns="36576" tIns="36576" bIns="36576" anchor="t">
+          <a:bodyPr wrap="square" lIns="36576" tIns="36576" rIns="36576" bIns="36576" anchor="t">
             <a:spAutoFit/>
           </a:bodyPr>
           <a:lstStyle/>
@@ -4548,6 +5774,7 @@
           <a:lstStyle/>
           <a:p>
             <a:pPr algn="ctr"/>
+            <a:endParaRPr/>
           </a:p>
         </p:txBody>
       </p:sp>
@@ -4568,7 +5795,7 @@
           <a:noFill/>
         </p:spPr>
         <p:txBody>
-          <a:bodyPr wrap="square" lIns="36576" rIns="36576" tIns="36576" bIns="36576" anchor="t">
+          <a:bodyPr wrap="square" lIns="36576" tIns="36576" rIns="36576" bIns="36576" anchor="t">
             <a:spAutoFit/>
           </a:bodyPr>
           <a:lstStyle/>
@@ -4607,7 +5834,7 @@
           <a:noFill/>
         </p:spPr>
         <p:txBody>
-          <a:bodyPr wrap="square" lIns="36576" rIns="36576" tIns="36576" bIns="36576" anchor="t">
+          <a:bodyPr wrap="square" lIns="36576" tIns="36576" rIns="36576" bIns="36576" anchor="t">
             <a:spAutoFit/>
           </a:bodyPr>
           <a:lstStyle/>
@@ -4669,6 +5896,7 @@
           <a:lstStyle/>
           <a:p>
             <a:pPr algn="ctr"/>
+            <a:endParaRPr/>
           </a:p>
         </p:txBody>
       </p:sp>
@@ -4689,7 +5917,7 @@
           <a:noFill/>
         </p:spPr>
         <p:txBody>
-          <a:bodyPr wrap="square" lIns="36576" rIns="36576" tIns="36576" bIns="36576" anchor="t">
+          <a:bodyPr wrap="square" lIns="36576" tIns="36576" rIns="36576" bIns="36576" anchor="t">
             <a:spAutoFit/>
           </a:bodyPr>
           <a:lstStyle/>
@@ -4728,7 +5956,7 @@
           <a:noFill/>
         </p:spPr>
         <p:txBody>
-          <a:bodyPr wrap="square" lIns="36576" rIns="36576" tIns="36576" bIns="36576" anchor="t">
+          <a:bodyPr wrap="square" lIns="36576" tIns="36576" rIns="36576" bIns="36576" anchor="t">
             <a:spAutoFit/>
           </a:bodyPr>
           <a:lstStyle/>
@@ -4790,6 +6018,7 @@
           <a:lstStyle/>
           <a:p>
             <a:pPr algn="ctr"/>
+            <a:endParaRPr/>
           </a:p>
         </p:txBody>
       </p:sp>
@@ -4810,7 +6039,7 @@
           <a:noFill/>
         </p:spPr>
         <p:txBody>
-          <a:bodyPr wrap="square" lIns="36576" rIns="36576" tIns="36576" bIns="36576" anchor="t">
+          <a:bodyPr wrap="square" lIns="36576" tIns="36576" rIns="36576" bIns="36576" anchor="t">
             <a:spAutoFit/>
           </a:bodyPr>
           <a:lstStyle/>
@@ -4849,7 +6078,7 @@
           <a:noFill/>
         </p:spPr>
         <p:txBody>
-          <a:bodyPr wrap="square" lIns="36576" rIns="36576" tIns="36576" bIns="36576" anchor="t">
+          <a:bodyPr wrap="square" lIns="36576" tIns="36576" rIns="36576" bIns="36576" anchor="t">
             <a:spAutoFit/>
           </a:bodyPr>
           <a:lstStyle/>
@@ -5053,6 +6282,7 @@
           <a:lstStyle/>
           <a:p>
             <a:pPr algn="ctr"/>
+            <a:endParaRPr/>
           </a:p>
         </p:txBody>
       </p:sp>
@@ -5096,6 +6326,7 @@
           <a:lstStyle/>
           <a:p>
             <a:pPr algn="ctr"/>
+            <a:endParaRPr/>
           </a:p>
         </p:txBody>
       </p:sp>
@@ -5116,7 +6347,7 @@
           <a:noFill/>
         </p:spPr>
         <p:txBody>
-          <a:bodyPr wrap="square" lIns="36576" rIns="36576" tIns="36576" bIns="36576" anchor="t">
+          <a:bodyPr wrap="square" lIns="36576" tIns="36576" rIns="36576" bIns="36576" anchor="t">
             <a:spAutoFit/>
           </a:bodyPr>
           <a:lstStyle/>
@@ -5155,7 +6386,7 @@
           <a:noFill/>
         </p:spPr>
         <p:txBody>
-          <a:bodyPr wrap="square" lIns="36576" rIns="36576" tIns="36576" bIns="36576" anchor="t">
+          <a:bodyPr wrap="square" lIns="36576" tIns="36576" rIns="36576" bIns="36576" anchor="t">
             <a:spAutoFit/>
           </a:bodyPr>
           <a:lstStyle/>
@@ -5219,6 +6450,7 @@
           <a:lstStyle/>
           <a:p>
             <a:pPr algn="ctr"/>
+            <a:endParaRPr/>
           </a:p>
         </p:txBody>
       </p:sp>
@@ -5262,6 +6494,7 @@
           <a:lstStyle/>
           <a:p>
             <a:pPr algn="ctr"/>
+            <a:endParaRPr/>
           </a:p>
         </p:txBody>
       </p:sp>
@@ -5282,7 +6515,7 @@
           <a:noFill/>
         </p:spPr>
         <p:txBody>
-          <a:bodyPr wrap="square" lIns="36576" rIns="36576" tIns="36576" bIns="36576" anchor="t">
+          <a:bodyPr wrap="square" lIns="36576" tIns="36576" rIns="36576" bIns="36576" anchor="t">
             <a:spAutoFit/>
           </a:bodyPr>
           <a:lstStyle/>
@@ -5321,7 +6554,7 @@
           <a:noFill/>
         </p:spPr>
         <p:txBody>
-          <a:bodyPr wrap="square" lIns="36576" rIns="36576" tIns="36576" bIns="36576" anchor="t">
+          <a:bodyPr wrap="square" lIns="36576" tIns="36576" rIns="36576" bIns="36576" anchor="t">
             <a:spAutoFit/>
           </a:bodyPr>
           <a:lstStyle/>
@@ -5348,11 +6581,23 @@
   <p:clrMapOvr>
     <a:masterClrMapping/>
   </p:clrMapOvr>
+  <mc:AlternateContent xmlns:mc="http://schemas.openxmlformats.org/markup-compatibility/2006" xmlns:p14="http://schemas.microsoft.com/office/powerpoint/2010/main">
+    <mc:Choice Requires="p14">
+      <p:transition spd="med" p14:dur="700">
+        <p:fade/>
+      </p:transition>
+    </mc:Choice>
+    <mc:Fallback xmlns="">
+      <p:transition spd="med">
+        <p:fade/>
+      </p:transition>
+    </mc:Fallback>
+  </mc:AlternateContent>
 </p:sld>
 </file>
 
-<file path=ppt/slides/slide5.xml><?xml version="1.0" encoding="utf-8"?>
-<p:sld xmlns:a="http://schemas.openxmlformats.org/drawingml/2006/main" xmlns:p="http://schemas.openxmlformats.org/presentationml/2006/main" xmlns:r="http://schemas.openxmlformats.org/officeDocument/2006/relationships">
+<file path=ppt/slides/slide4.xml><?xml version="1.0" encoding="utf-8"?>
+<p:sld xmlns:a="http://schemas.openxmlformats.org/drawingml/2006/main" xmlns:r="http://schemas.openxmlformats.org/officeDocument/2006/relationships" xmlns:p="http://schemas.openxmlformats.org/presentationml/2006/main">
   <p:cSld>
     <p:bg>
       <p:bgPr>
@@ -5368,7 +6613,14 @@
         <p:cNvGrpSpPr/>
         <p:nvPr/>
       </p:nvGrpSpPr>
-      <p:grpSpPr/>
+      <p:grpSpPr>
+        <a:xfrm>
+          <a:off x="0" y="0"/>
+          <a:ext cx="0" cy="0"/>
+          <a:chOff x="0" y="0"/>
+          <a:chExt cx="0" cy="0"/>
+        </a:xfrm>
+      </p:grpSpPr>
       <p:sp>
         <p:nvSpPr>
           <p:cNvPr id="2" name="TextBox 1"/>
@@ -5386,7 +6638,7 @@
           <a:noFill/>
         </p:spPr>
         <p:txBody>
-          <a:bodyPr wrap="square" lIns="36576" rIns="36576" tIns="36576" bIns="36576" anchor="t">
+          <a:bodyPr wrap="square" lIns="36576" tIns="36576" rIns="36576" bIns="36576" anchor="t">
             <a:spAutoFit/>
           </a:bodyPr>
           <a:lstStyle/>
@@ -5425,7 +6677,7 @@
           <a:noFill/>
         </p:spPr>
         <p:txBody>
-          <a:bodyPr wrap="square" lIns="36576" rIns="36576" tIns="36576" bIns="36576" anchor="t">
+          <a:bodyPr wrap="square" lIns="36576" tIns="36576" rIns="36576" bIns="36576" anchor="t">
             <a:spAutoFit/>
           </a:bodyPr>
           <a:lstStyle/>
@@ -5487,6 +6739,7 @@
           <a:lstStyle/>
           <a:p>
             <a:pPr algn="ctr"/>
+            <a:endParaRPr/>
           </a:p>
         </p:txBody>
       </p:sp>
@@ -5507,7 +6760,7 @@
           <a:noFill/>
         </p:spPr>
         <p:txBody>
-          <a:bodyPr wrap="square" lIns="36576" rIns="36576" tIns="36576" bIns="36576" anchor="t">
+          <a:bodyPr wrap="square" lIns="36576" tIns="36576" rIns="36576" bIns="36576" anchor="t">
             <a:spAutoFit/>
           </a:bodyPr>
           <a:lstStyle/>
@@ -5546,7 +6799,7 @@
           <a:noFill/>
         </p:spPr>
         <p:txBody>
-          <a:bodyPr wrap="square" lIns="36576" rIns="36576" tIns="36576" bIns="36576" anchor="t">
+          <a:bodyPr wrap="square" lIns="36576" tIns="36576" rIns="36576" bIns="36576" anchor="t">
             <a:spAutoFit/>
           </a:bodyPr>
           <a:lstStyle/>
@@ -5585,7 +6838,7 @@
           <a:noFill/>
         </p:spPr>
         <p:txBody>
-          <a:bodyPr wrap="square" lIns="36576" rIns="36576" tIns="36576" bIns="36576" anchor="t">
+          <a:bodyPr wrap="square" lIns="36576" tIns="36576" rIns="36576" bIns="36576" anchor="t">
             <a:spAutoFit/>
           </a:bodyPr>
           <a:lstStyle/>
@@ -5610,112 +6863,6 @@
       <p:pic>
         <p:nvPicPr>
           <p:cNvPr id="8" name="Picture 7" descr="old_location.png"/>
-          <p:cNvPicPr>
-            <a:picLocks noChangeAspect="1"/>
-          </p:cNvPicPr>
-          <p:nvPr/>
-        </p:nvPicPr>
-        <p:blipFill>
-          <a:blip r:embed="rId2"/>
-          <a:stretch>
-            <a:fillRect/>
-          </a:stretch>
-        </p:blipFill>
-        <p:spPr>
-          <a:xfrm>
-            <a:off x="1851183" y="1783080"/>
-            <a:ext cx="2332672" cy="4251960"/>
-          </a:xfrm>
-          <a:prstGeom prst="rect">
-            <a:avLst/>
-          </a:prstGeom>
-        </p:spPr>
-      </p:pic>
-      <p:sp>
-        <p:nvSpPr>
-          <p:cNvPr id="9" name="Rounded Rectangle 8"/>
-          <p:cNvSpPr/>
-          <p:nvPr/>
-        </p:nvSpPr>
-        <p:spPr>
-          <a:xfrm>
-            <a:off x="1851183" y="1783080"/>
-            <a:ext cx="2332672" cy="4251960"/>
-          </a:xfrm>
-          <a:prstGeom prst="roundRect">
-            <a:avLst/>
-          </a:prstGeom>
-          <a:noFill/>
-          <a:ln w="15240">
-            <a:solidFill>
-              <a:srgbClr val="415774"/>
-            </a:solidFill>
-          </a:ln>
-        </p:spPr>
-        <p:style>
-          <a:lnRef idx="1">
-            <a:schemeClr val="accent1"/>
-          </a:lnRef>
-          <a:fillRef idx="3">
-            <a:schemeClr val="accent1"/>
-          </a:fillRef>
-          <a:effectRef idx="2">
-            <a:schemeClr val="accent1"/>
-          </a:effectRef>
-          <a:fontRef idx="minor">
-            <a:schemeClr val="lt1"/>
-          </a:fontRef>
-        </p:style>
-        <p:txBody>
-          <a:bodyPr rtlCol="0" anchor="ctr"/>
-          <a:lstStyle/>
-          <a:p>
-            <a:pPr algn="ctr"/>
-          </a:p>
-        </p:txBody>
-      </p:sp>
-      <p:sp>
-        <p:nvSpPr>
-          <p:cNvPr id="10" name="TextBox 9"/>
-          <p:cNvSpPr txBox="1"/>
-          <p:nvPr/>
-        </p:nvSpPr>
-        <p:spPr>
-          <a:xfrm>
-            <a:off x="6446520" y="1444752"/>
-            <a:ext cx="3931920" cy="274320"/>
-          </a:xfrm>
-          <a:prstGeom prst="rect">
-            <a:avLst/>
-          </a:prstGeom>
-          <a:noFill/>
-        </p:spPr>
-        <p:txBody>
-          <a:bodyPr wrap="square" lIns="36576" rIns="36576" tIns="36576" bIns="36576" anchor="t">
-            <a:spAutoFit/>
-          </a:bodyPr>
-          <a:lstStyle/>
-          <a:p>
-            <a:pPr algn="ctr">
-              <a:spcAft>
-                <a:spcPts val="500"/>
-              </a:spcAft>
-              <a:defRPr sz="1400" b="1">
-                <a:solidFill>
-                  <a:srgbClr val="2CB07D"/>
-                </a:solidFill>
-                <a:latin typeface="Aptos"/>
-              </a:defRPr>
-            </a:pPr>
-            <a:r>
-              <a:t>REDESIGNED UI</a:t>
-            </a:r>
-          </a:p>
-        </p:txBody>
-      </p:sp>
-      <p:pic>
-        <p:nvPicPr>
-          <p:cNvPr id="11" name="Picture 10" descr="new_location.png"/>
           <p:cNvPicPr>
             <a:picLocks noChangeAspect="1"/>
           </p:cNvPicPr>
@@ -5729,8 +6876,8 @@
         </p:blipFill>
         <p:spPr>
           <a:xfrm>
-            <a:off x="7246143" y="1783080"/>
-            <a:ext cx="2332672" cy="4251960"/>
+            <a:off x="1965959" y="1783080"/>
+            <a:ext cx="2103120" cy="3611880"/>
           </a:xfrm>
           <a:prstGeom prst="rect">
             <a:avLst/>
@@ -5739,14 +6886,14 @@
       </p:pic>
       <p:sp>
         <p:nvSpPr>
-          <p:cNvPr id="12" name="Rounded Rectangle 11"/>
+          <p:cNvPr id="9" name="Rounded Rectangle 8"/>
           <p:cNvSpPr/>
           <p:nvPr/>
         </p:nvSpPr>
         <p:spPr>
           <a:xfrm>
-            <a:off x="7246143" y="1783080"/>
-            <a:ext cx="2332672" cy="4251960"/>
+            <a:off x="1965959" y="1783080"/>
+            <a:ext cx="2103120" cy="3611880"/>
           </a:xfrm>
           <a:prstGeom prst="roundRect">
             <a:avLst/>
@@ -5777,6 +6924,114 @@
           <a:lstStyle/>
           <a:p>
             <a:pPr algn="ctr"/>
+            <a:endParaRPr/>
+          </a:p>
+        </p:txBody>
+      </p:sp>
+      <p:sp>
+        <p:nvSpPr>
+          <p:cNvPr id="10" name="TextBox 9"/>
+          <p:cNvSpPr txBox="1"/>
+          <p:nvPr/>
+        </p:nvSpPr>
+        <p:spPr>
+          <a:xfrm>
+            <a:off x="6446520" y="1444752"/>
+            <a:ext cx="3931920" cy="274320"/>
+          </a:xfrm>
+          <a:prstGeom prst="rect">
+            <a:avLst/>
+          </a:prstGeom>
+          <a:noFill/>
+        </p:spPr>
+        <p:txBody>
+          <a:bodyPr wrap="square" lIns="36576" tIns="36576" rIns="36576" bIns="36576" anchor="t">
+            <a:spAutoFit/>
+          </a:bodyPr>
+          <a:lstStyle/>
+          <a:p>
+            <a:pPr algn="ctr">
+              <a:spcAft>
+                <a:spcPts val="500"/>
+              </a:spcAft>
+              <a:defRPr sz="1400" b="1">
+                <a:solidFill>
+                  <a:srgbClr val="2CB07D"/>
+                </a:solidFill>
+                <a:latin typeface="Aptos"/>
+              </a:defRPr>
+            </a:pPr>
+            <a:r>
+              <a:t>REDESIGNED UI</a:t>
+            </a:r>
+          </a:p>
+        </p:txBody>
+      </p:sp>
+      <p:pic>
+        <p:nvPicPr>
+          <p:cNvPr id="11" name="Picture 10" descr="new_location.png"/>
+          <p:cNvPicPr>
+            <a:picLocks noChangeAspect="1"/>
+          </p:cNvPicPr>
+          <p:nvPr/>
+        </p:nvPicPr>
+        <p:blipFill>
+          <a:blip r:embed="rId4"/>
+          <a:stretch>
+            <a:fillRect/>
+          </a:stretch>
+        </p:blipFill>
+        <p:spPr>
+          <a:xfrm>
+            <a:off x="7360919" y="1783080"/>
+            <a:ext cx="2103120" cy="3611880"/>
+          </a:xfrm>
+          <a:prstGeom prst="rect">
+            <a:avLst/>
+          </a:prstGeom>
+        </p:spPr>
+      </p:pic>
+      <p:sp>
+        <p:nvSpPr>
+          <p:cNvPr id="12" name="Rounded Rectangle 11"/>
+          <p:cNvSpPr/>
+          <p:nvPr/>
+        </p:nvSpPr>
+        <p:spPr>
+          <a:xfrm>
+            <a:off x="7360919" y="1783080"/>
+            <a:ext cx="2103120" cy="3611880"/>
+          </a:xfrm>
+          <a:prstGeom prst="roundRect">
+            <a:avLst/>
+          </a:prstGeom>
+          <a:noFill/>
+          <a:ln w="15240">
+            <a:solidFill>
+              <a:srgbClr val="415774"/>
+            </a:solidFill>
+          </a:ln>
+        </p:spPr>
+        <p:style>
+          <a:lnRef idx="1">
+            <a:schemeClr val="accent1"/>
+          </a:lnRef>
+          <a:fillRef idx="3">
+            <a:schemeClr val="accent1"/>
+          </a:fillRef>
+          <a:effectRef idx="2">
+            <a:schemeClr val="accent1"/>
+          </a:effectRef>
+          <a:fontRef idx="minor">
+            <a:schemeClr val="lt1"/>
+          </a:fontRef>
+        </p:style>
+        <p:txBody>
+          <a:bodyPr rtlCol="0" anchor="ctr"/>
+          <a:lstStyle/>
+          <a:p>
+            <a:pPr algn="ctr"/>
+            <a:endParaRPr/>
           </a:p>
         </p:txBody>
       </p:sp>
@@ -5788,8 +7043,8 @@
         </p:nvSpPr>
         <p:spPr>
           <a:xfrm>
-            <a:off x="1828800" y="5715000"/>
-            <a:ext cx="8549640" cy="594360"/>
+            <a:off x="1741932" y="5577840"/>
+            <a:ext cx="8549640" cy="694944"/>
           </a:xfrm>
           <a:prstGeom prst="roundRect">
             <a:avLst/>
@@ -5822,6 +7077,7 @@
           <a:lstStyle/>
           <a:p>
             <a:pPr algn="ctr"/>
+            <a:endParaRPr/>
           </a:p>
         </p:txBody>
       </p:sp>
@@ -5833,8 +7089,8 @@
         </p:nvSpPr>
         <p:spPr>
           <a:xfrm>
-            <a:off x="1828800" y="5715000"/>
-            <a:ext cx="54864" cy="594360"/>
+            <a:off x="1828800" y="5559552"/>
+            <a:ext cx="54864" cy="694944"/>
           </a:xfrm>
           <a:prstGeom prst="rect">
             <a:avLst/>
@@ -5865,6 +7121,7 @@
           <a:lstStyle/>
           <a:p>
             <a:pPr algn="ctr"/>
+            <a:endParaRPr/>
           </a:p>
         </p:txBody>
       </p:sp>
@@ -5876,8 +7133,8 @@
         </p:nvSpPr>
         <p:spPr>
           <a:xfrm>
-            <a:off x="2011680" y="5852160"/>
-            <a:ext cx="8229600" cy="274320"/>
+            <a:off x="2029968" y="5722358"/>
+            <a:ext cx="8138160" cy="184666"/>
           </a:xfrm>
           <a:prstGeom prst="rect">
             <a:avLst/>
@@ -5885,7 +7142,7 @@
           <a:noFill/>
         </p:spPr>
         <p:txBody>
-          <a:bodyPr wrap="square" lIns="36576" rIns="36576" tIns="36576" bIns="36576" anchor="t">
+          <a:bodyPr wrap="square" lIns="0" tIns="0" rIns="0" bIns="0" anchor="ctr">
             <a:spAutoFit/>
           </a:bodyPr>
           <a:lstStyle/>
@@ -5894,14 +7151,19 @@
               <a:spcAft>
                 <a:spcPts val="500"/>
               </a:spcAft>
-              <a:defRPr sz="1500" b="1">
-                <a:solidFill>
-                  <a:srgbClr val="F8FAFD"/>
+              <a:defRPr sz="1200" b="1">
+                <a:solidFill>
+                  <a:srgbClr val="22583B"/>
                 </a:solidFill>
                 <a:latin typeface="Aptos"/>
               </a:defRPr>
             </a:pPr>
             <a:r>
+              <a:rPr dirty="0">
+                <a:solidFill>
+                  <a:srgbClr val="92D050"/>
+                </a:solidFill>
+              </a:rPr>
               <a:t>What changed</a:t>
             </a:r>
           </a:p>
@@ -5915,8 +7177,8 @@
         </p:nvSpPr>
         <p:spPr>
           <a:xfrm>
-            <a:off x="2011680" y="6217920"/>
-            <a:ext cx="8202167" cy="0"/>
+            <a:off x="2029968" y="6016751"/>
+            <a:ext cx="8138160" cy="138499"/>
           </a:xfrm>
           <a:prstGeom prst="rect">
             <a:avLst/>
@@ -5924,7 +7186,7 @@
           <a:noFill/>
         </p:spPr>
         <p:txBody>
-          <a:bodyPr wrap="square" lIns="36576" rIns="36576" tIns="36576" bIns="36576" anchor="t">
+          <a:bodyPr wrap="square" lIns="0" tIns="0" rIns="0" bIns="0" anchor="ctr">
             <a:spAutoFit/>
           </a:bodyPr>
           <a:lstStyle/>
@@ -5933,15 +7195,20 @@
               <a:spcAft>
                 <a:spcPts val="500"/>
               </a:spcAft>
-              <a:defRPr sz="1100" b="0">
-                <a:solidFill>
-                  <a:srgbClr val="E0EAF6"/>
+              <a:defRPr sz="900" b="0">
+                <a:solidFill>
+                  <a:srgbClr val="465049"/>
                 </a:solidFill>
                 <a:latin typeface="Aptos"/>
               </a:defRPr>
             </a:pPr>
             <a:r>
-              <a:t>The QR flow is designed to resolve the outlet ID and open the matching menu.</a:t>
+              <a:rPr dirty="0">
+                <a:solidFill>
+                  <a:schemeClr val="bg1"/>
+                </a:solidFill>
+              </a:rPr>
+              <a:t>QR access is designed to identify the outlet and open its matching menu.</a:t>
             </a:r>
           </a:p>
         </p:txBody>
@@ -5951,11 +7218,23 @@
   <p:clrMapOvr>
     <a:masterClrMapping/>
   </p:clrMapOvr>
+  <mc:AlternateContent xmlns:mc="http://schemas.openxmlformats.org/markup-compatibility/2006" xmlns:p14="http://schemas.microsoft.com/office/powerpoint/2010/main">
+    <mc:Choice Requires="p14">
+      <p:transition spd="med" p14:dur="700">
+        <p:fade/>
+      </p:transition>
+    </mc:Choice>
+    <mc:Fallback xmlns="">
+      <p:transition spd="med">
+        <p:fade/>
+      </p:transition>
+    </mc:Fallback>
+  </mc:AlternateContent>
 </p:sld>
 </file>
 
-<file path=ppt/slides/slide6.xml><?xml version="1.0" encoding="utf-8"?>
-<p:sld xmlns:a="http://schemas.openxmlformats.org/drawingml/2006/main" xmlns:p="http://schemas.openxmlformats.org/presentationml/2006/main" xmlns:r="http://schemas.openxmlformats.org/officeDocument/2006/relationships">
+<file path=ppt/slides/slide5.xml><?xml version="1.0" encoding="utf-8"?>
+<p:sld xmlns:a="http://schemas.openxmlformats.org/drawingml/2006/main" xmlns:r="http://schemas.openxmlformats.org/officeDocument/2006/relationships" xmlns:p="http://schemas.openxmlformats.org/presentationml/2006/main">
   <p:cSld>
     <p:bg>
       <p:bgPr>
@@ -5971,7 +7250,14 @@
         <p:cNvGrpSpPr/>
         <p:nvPr/>
       </p:nvGrpSpPr>
-      <p:grpSpPr/>
+      <p:grpSpPr>
+        <a:xfrm>
+          <a:off x="0" y="0"/>
+          <a:ext cx="0" cy="0"/>
+          <a:chOff x="0" y="0"/>
+          <a:chExt cx="0" cy="0"/>
+        </a:xfrm>
+      </p:grpSpPr>
       <p:sp>
         <p:nvSpPr>
           <p:cNvPr id="2" name="TextBox 1"/>
@@ -5989,7 +7275,7 @@
           <a:noFill/>
         </p:spPr>
         <p:txBody>
-          <a:bodyPr wrap="square" lIns="36576" rIns="36576" tIns="36576" bIns="36576" anchor="t">
+          <a:bodyPr wrap="square" lIns="36576" tIns="36576" rIns="36576" bIns="36576" anchor="t">
             <a:spAutoFit/>
           </a:bodyPr>
           <a:lstStyle/>
@@ -6028,7 +7314,7 @@
           <a:noFill/>
         </p:spPr>
         <p:txBody>
-          <a:bodyPr wrap="square" lIns="36576" rIns="36576" tIns="36576" bIns="36576" anchor="t">
+          <a:bodyPr wrap="square" lIns="36576" tIns="36576" rIns="36576" bIns="36576" anchor="t">
             <a:spAutoFit/>
           </a:bodyPr>
           <a:lstStyle/>
@@ -6090,6 +7376,7 @@
           <a:lstStyle/>
           <a:p>
             <a:pPr algn="ctr"/>
+            <a:endParaRPr/>
           </a:p>
         </p:txBody>
       </p:sp>
@@ -6101,7 +7388,7 @@
         </p:nvSpPr>
         <p:spPr>
           <a:xfrm>
-            <a:off x="621792" y="6510528"/>
+            <a:off x="621792" y="6530192"/>
             <a:ext cx="7772400" cy="164592"/>
           </a:xfrm>
           <a:prstGeom prst="rect">
@@ -6110,7 +7397,7 @@
           <a:noFill/>
         </p:spPr>
         <p:txBody>
-          <a:bodyPr wrap="square" lIns="36576" rIns="36576" tIns="36576" bIns="36576" anchor="t">
+          <a:bodyPr wrap="square" lIns="36576" tIns="36576" rIns="36576" bIns="36576" anchor="t">
             <a:spAutoFit/>
           </a:bodyPr>
           <a:lstStyle/>
@@ -6149,7 +7436,7 @@
           <a:noFill/>
         </p:spPr>
         <p:txBody>
-          <a:bodyPr wrap="square" lIns="36576" rIns="36576" tIns="36576" bIns="36576" anchor="t">
+          <a:bodyPr wrap="square" lIns="36576" tIns="36576" rIns="36576" bIns="36576" anchor="t">
             <a:spAutoFit/>
           </a:bodyPr>
           <a:lstStyle/>
@@ -6188,7 +7475,7 @@
           <a:noFill/>
         </p:spPr>
         <p:txBody>
-          <a:bodyPr wrap="square" lIns="36576" rIns="36576" tIns="36576" bIns="36576" anchor="t">
+          <a:bodyPr wrap="square" lIns="36576" tIns="36576" rIns="36576" bIns="36576" anchor="t">
             <a:spAutoFit/>
           </a:bodyPr>
           <a:lstStyle/>
@@ -6213,112 +7500,6 @@
       <p:pic>
         <p:nvPicPr>
           <p:cNvPr id="8" name="Picture 7" descr="old_menu.png"/>
-          <p:cNvPicPr>
-            <a:picLocks noChangeAspect="1"/>
-          </p:cNvPicPr>
-          <p:nvPr/>
-        </p:nvPicPr>
-        <p:blipFill>
-          <a:blip r:embed="rId2"/>
-          <a:stretch>
-            <a:fillRect/>
-          </a:stretch>
-        </p:blipFill>
-        <p:spPr>
-          <a:xfrm>
-            <a:off x="1851183" y="1783080"/>
-            <a:ext cx="2332672" cy="4251960"/>
-          </a:xfrm>
-          <a:prstGeom prst="rect">
-            <a:avLst/>
-          </a:prstGeom>
-        </p:spPr>
-      </p:pic>
-      <p:sp>
-        <p:nvSpPr>
-          <p:cNvPr id="9" name="Rounded Rectangle 8"/>
-          <p:cNvSpPr/>
-          <p:nvPr/>
-        </p:nvSpPr>
-        <p:spPr>
-          <a:xfrm>
-            <a:off x="1851183" y="1783080"/>
-            <a:ext cx="2332672" cy="4251960"/>
-          </a:xfrm>
-          <a:prstGeom prst="roundRect">
-            <a:avLst/>
-          </a:prstGeom>
-          <a:noFill/>
-          <a:ln w="15240">
-            <a:solidFill>
-              <a:srgbClr val="415774"/>
-            </a:solidFill>
-          </a:ln>
-        </p:spPr>
-        <p:style>
-          <a:lnRef idx="1">
-            <a:schemeClr val="accent1"/>
-          </a:lnRef>
-          <a:fillRef idx="3">
-            <a:schemeClr val="accent1"/>
-          </a:fillRef>
-          <a:effectRef idx="2">
-            <a:schemeClr val="accent1"/>
-          </a:effectRef>
-          <a:fontRef idx="minor">
-            <a:schemeClr val="lt1"/>
-          </a:fontRef>
-        </p:style>
-        <p:txBody>
-          <a:bodyPr rtlCol="0" anchor="ctr"/>
-          <a:lstStyle/>
-          <a:p>
-            <a:pPr algn="ctr"/>
-          </a:p>
-        </p:txBody>
-      </p:sp>
-      <p:sp>
-        <p:nvSpPr>
-          <p:cNvPr id="10" name="TextBox 9"/>
-          <p:cNvSpPr txBox="1"/>
-          <p:nvPr/>
-        </p:nvSpPr>
-        <p:spPr>
-          <a:xfrm>
-            <a:off x="6446520" y="1444752"/>
-            <a:ext cx="3931920" cy="274320"/>
-          </a:xfrm>
-          <a:prstGeom prst="rect">
-            <a:avLst/>
-          </a:prstGeom>
-          <a:noFill/>
-        </p:spPr>
-        <p:txBody>
-          <a:bodyPr wrap="square" lIns="36576" rIns="36576" tIns="36576" bIns="36576" anchor="t">
-            <a:spAutoFit/>
-          </a:bodyPr>
-          <a:lstStyle/>
-          <a:p>
-            <a:pPr algn="ctr">
-              <a:spcAft>
-                <a:spcPts val="500"/>
-              </a:spcAft>
-              <a:defRPr sz="1400" b="1">
-                <a:solidFill>
-                  <a:srgbClr val="2CB07D"/>
-                </a:solidFill>
-                <a:latin typeface="Aptos"/>
-              </a:defRPr>
-            </a:pPr>
-            <a:r>
-              <a:t>REDESIGNED UI</a:t>
-            </a:r>
-          </a:p>
-        </p:txBody>
-      </p:sp>
-      <p:pic>
-        <p:nvPicPr>
-          <p:cNvPr id="11" name="Picture 10" descr="new_menu.png"/>
           <p:cNvPicPr>
             <a:picLocks noChangeAspect="1"/>
           </p:cNvPicPr>
@@ -6332,8 +7513,8 @@
         </p:blipFill>
         <p:spPr>
           <a:xfrm>
-            <a:off x="7246143" y="1783080"/>
-            <a:ext cx="2332672" cy="4251960"/>
+            <a:off x="1965959" y="1783080"/>
+            <a:ext cx="2103120" cy="3611880"/>
           </a:xfrm>
           <a:prstGeom prst="rect">
             <a:avLst/>
@@ -6342,14 +7523,14 @@
       </p:pic>
       <p:sp>
         <p:nvSpPr>
-          <p:cNvPr id="12" name="Rounded Rectangle 11"/>
+          <p:cNvPr id="9" name="Rounded Rectangle 8"/>
           <p:cNvSpPr/>
           <p:nvPr/>
         </p:nvSpPr>
         <p:spPr>
           <a:xfrm>
-            <a:off x="7246143" y="1783080"/>
-            <a:ext cx="2332672" cy="4251960"/>
+            <a:off x="1965959" y="1783080"/>
+            <a:ext cx="2103120" cy="3611880"/>
           </a:xfrm>
           <a:prstGeom prst="roundRect">
             <a:avLst/>
@@ -6380,6 +7561,114 @@
           <a:lstStyle/>
           <a:p>
             <a:pPr algn="ctr"/>
+            <a:endParaRPr/>
+          </a:p>
+        </p:txBody>
+      </p:sp>
+      <p:sp>
+        <p:nvSpPr>
+          <p:cNvPr id="10" name="TextBox 9"/>
+          <p:cNvSpPr txBox="1"/>
+          <p:nvPr/>
+        </p:nvSpPr>
+        <p:spPr>
+          <a:xfrm>
+            <a:off x="6446520" y="1444752"/>
+            <a:ext cx="3931920" cy="274320"/>
+          </a:xfrm>
+          <a:prstGeom prst="rect">
+            <a:avLst/>
+          </a:prstGeom>
+          <a:noFill/>
+        </p:spPr>
+        <p:txBody>
+          <a:bodyPr wrap="square" lIns="36576" tIns="36576" rIns="36576" bIns="36576" anchor="t">
+            <a:spAutoFit/>
+          </a:bodyPr>
+          <a:lstStyle/>
+          <a:p>
+            <a:pPr algn="ctr">
+              <a:spcAft>
+                <a:spcPts val="500"/>
+              </a:spcAft>
+              <a:defRPr sz="1400" b="1">
+                <a:solidFill>
+                  <a:srgbClr val="2CB07D"/>
+                </a:solidFill>
+                <a:latin typeface="Aptos"/>
+              </a:defRPr>
+            </a:pPr>
+            <a:r>
+              <a:t>REDESIGNED UI</a:t>
+            </a:r>
+          </a:p>
+        </p:txBody>
+      </p:sp>
+      <p:pic>
+        <p:nvPicPr>
+          <p:cNvPr id="11" name="Picture 10" descr="new_menu.png"/>
+          <p:cNvPicPr>
+            <a:picLocks noChangeAspect="1"/>
+          </p:cNvPicPr>
+          <p:nvPr/>
+        </p:nvPicPr>
+        <p:blipFill>
+          <a:blip r:embed="rId4"/>
+          <a:stretch>
+            <a:fillRect/>
+          </a:stretch>
+        </p:blipFill>
+        <p:spPr>
+          <a:xfrm>
+            <a:off x="7360919" y="1783080"/>
+            <a:ext cx="2103120" cy="3611880"/>
+          </a:xfrm>
+          <a:prstGeom prst="rect">
+            <a:avLst/>
+          </a:prstGeom>
+        </p:spPr>
+      </p:pic>
+      <p:sp>
+        <p:nvSpPr>
+          <p:cNvPr id="12" name="Rounded Rectangle 11"/>
+          <p:cNvSpPr/>
+          <p:nvPr/>
+        </p:nvSpPr>
+        <p:spPr>
+          <a:xfrm>
+            <a:off x="7360919" y="1783080"/>
+            <a:ext cx="2103120" cy="3611880"/>
+          </a:xfrm>
+          <a:prstGeom prst="roundRect">
+            <a:avLst/>
+          </a:prstGeom>
+          <a:noFill/>
+          <a:ln w="15240">
+            <a:solidFill>
+              <a:srgbClr val="415774"/>
+            </a:solidFill>
+          </a:ln>
+        </p:spPr>
+        <p:style>
+          <a:lnRef idx="1">
+            <a:schemeClr val="accent1"/>
+          </a:lnRef>
+          <a:fillRef idx="3">
+            <a:schemeClr val="accent1"/>
+          </a:fillRef>
+          <a:effectRef idx="2">
+            <a:schemeClr val="accent1"/>
+          </a:effectRef>
+          <a:fontRef idx="minor">
+            <a:schemeClr val="lt1"/>
+          </a:fontRef>
+        </p:style>
+        <p:txBody>
+          <a:bodyPr rtlCol="0" anchor="ctr"/>
+          <a:lstStyle/>
+          <a:p>
+            <a:pPr algn="ctr"/>
+            <a:endParaRPr/>
           </a:p>
         </p:txBody>
       </p:sp>
@@ -6391,8 +7680,8 @@
         </p:nvSpPr>
         <p:spPr>
           <a:xfrm>
-            <a:off x="1828800" y="5715000"/>
-            <a:ext cx="8549640" cy="594360"/>
+            <a:off x="1805940" y="5559552"/>
+            <a:ext cx="8549640" cy="694944"/>
           </a:xfrm>
           <a:prstGeom prst="roundRect">
             <a:avLst/>
@@ -6425,6 +7714,7 @@
           <a:lstStyle/>
           <a:p>
             <a:pPr algn="ctr"/>
+            <a:endParaRPr/>
           </a:p>
         </p:txBody>
       </p:sp>
@@ -6436,8 +7726,8 @@
         </p:nvSpPr>
         <p:spPr>
           <a:xfrm>
-            <a:off x="1828800" y="5715000"/>
-            <a:ext cx="54864" cy="594360"/>
+            <a:off x="1828800" y="5559552"/>
+            <a:ext cx="54864" cy="694944"/>
           </a:xfrm>
           <a:prstGeom prst="rect">
             <a:avLst/>
@@ -6468,6 +7758,7 @@
           <a:lstStyle/>
           <a:p>
             <a:pPr algn="ctr"/>
+            <a:endParaRPr/>
           </a:p>
         </p:txBody>
       </p:sp>
@@ -6479,8 +7770,8 @@
         </p:nvSpPr>
         <p:spPr>
           <a:xfrm>
-            <a:off x="2011680" y="5852160"/>
-            <a:ext cx="8229600" cy="274320"/>
+            <a:off x="2029968" y="5680540"/>
+            <a:ext cx="8138160" cy="184666"/>
           </a:xfrm>
           <a:prstGeom prst="rect">
             <a:avLst/>
@@ -6488,7 +7779,7 @@
           <a:noFill/>
         </p:spPr>
         <p:txBody>
-          <a:bodyPr wrap="square" lIns="36576" rIns="36576" tIns="36576" bIns="36576" anchor="t">
+          <a:bodyPr wrap="square" lIns="0" tIns="0" rIns="0" bIns="0" anchor="ctr">
             <a:spAutoFit/>
           </a:bodyPr>
           <a:lstStyle/>
@@ -6497,14 +7788,19 @@
               <a:spcAft>
                 <a:spcPts val="500"/>
               </a:spcAft>
-              <a:defRPr sz="1500" b="1">
-                <a:solidFill>
-                  <a:srgbClr val="F8FAFD"/>
+              <a:defRPr sz="1200" b="1">
+                <a:solidFill>
+                  <a:srgbClr val="22583B"/>
                 </a:solidFill>
                 <a:latin typeface="Aptos"/>
               </a:defRPr>
             </a:pPr>
             <a:r>
+              <a:rPr dirty="0">
+                <a:solidFill>
+                  <a:schemeClr val="accent3"/>
+                </a:solidFill>
+              </a:rPr>
               <a:t>What changed</a:t>
             </a:r>
           </a:p>
@@ -6518,8 +7814,8 @@
         </p:nvSpPr>
         <p:spPr>
           <a:xfrm>
-            <a:off x="2011680" y="6217920"/>
-            <a:ext cx="8202167" cy="0"/>
+            <a:off x="2029968" y="5947502"/>
+            <a:ext cx="8138160" cy="138499"/>
           </a:xfrm>
           <a:prstGeom prst="rect">
             <a:avLst/>
@@ -6527,7 +7823,7 @@
           <a:noFill/>
         </p:spPr>
         <p:txBody>
-          <a:bodyPr wrap="square" lIns="36576" rIns="36576" tIns="36576" bIns="36576" anchor="t">
+          <a:bodyPr wrap="square" lIns="0" tIns="0" rIns="0" bIns="0" anchor="ctr">
             <a:spAutoFit/>
           </a:bodyPr>
           <a:lstStyle/>
@@ -6536,15 +7832,20 @@
               <a:spcAft>
                 <a:spcPts val="500"/>
               </a:spcAft>
-              <a:defRPr sz="1100" b="0">
-                <a:solidFill>
-                  <a:srgbClr val="E0EAF6"/>
+              <a:defRPr sz="900" b="0">
+                <a:solidFill>
+                  <a:srgbClr val="465049"/>
                 </a:solidFill>
                 <a:latin typeface="Aptos"/>
               </a:defRPr>
             </a:pPr>
             <a:r>
-              <a:t>The UI redesign changes presentation; item names, prices, and availability should still come from the existing menu API.</a:t>
+              <a:rPr dirty="0">
+                <a:solidFill>
+                  <a:schemeClr val="bg1"/>
+                </a:solidFill>
+              </a:rPr>
+              <a:t>The refreshed menu improves browsing; item names, prices, and availability remain API-driven.</a:t>
             </a:r>
           </a:p>
         </p:txBody>
@@ -6554,11 +7855,23 @@
   <p:clrMapOvr>
     <a:masterClrMapping/>
   </p:clrMapOvr>
+  <mc:AlternateContent xmlns:mc="http://schemas.openxmlformats.org/markup-compatibility/2006" xmlns:p14="http://schemas.microsoft.com/office/powerpoint/2010/main">
+    <mc:Choice Requires="p14">
+      <p:transition spd="med" p14:dur="700">
+        <p:fade/>
+      </p:transition>
+    </mc:Choice>
+    <mc:Fallback xmlns="">
+      <p:transition spd="med">
+        <p:fade/>
+      </p:transition>
+    </mc:Fallback>
+  </mc:AlternateContent>
 </p:sld>
 </file>
 
-<file path=ppt/slides/slide7.xml><?xml version="1.0" encoding="utf-8"?>
-<p:sld xmlns:a="http://schemas.openxmlformats.org/drawingml/2006/main" xmlns:p="http://schemas.openxmlformats.org/presentationml/2006/main" xmlns:r="http://schemas.openxmlformats.org/officeDocument/2006/relationships">
+<file path=ppt/slides/slide6.xml><?xml version="1.0" encoding="utf-8"?>
+<p:sld xmlns:a="http://schemas.openxmlformats.org/drawingml/2006/main" xmlns:r="http://schemas.openxmlformats.org/officeDocument/2006/relationships" xmlns:p="http://schemas.openxmlformats.org/presentationml/2006/main">
   <p:cSld>
     <p:bg>
       <p:bgPr>
@@ -6574,7 +7887,14 @@
         <p:cNvGrpSpPr/>
         <p:nvPr/>
       </p:nvGrpSpPr>
-      <p:grpSpPr/>
+      <p:grpSpPr>
+        <a:xfrm>
+          <a:off x="0" y="0"/>
+          <a:ext cx="0" cy="0"/>
+          <a:chOff x="0" y="0"/>
+          <a:chExt cx="0" cy="0"/>
+        </a:xfrm>
+      </p:grpSpPr>
       <p:sp>
         <p:nvSpPr>
           <p:cNvPr id="2" name="TextBox 1"/>
@@ -6592,7 +7912,7 @@
           <a:noFill/>
         </p:spPr>
         <p:txBody>
-          <a:bodyPr wrap="square" lIns="36576" rIns="36576" tIns="36576" bIns="36576" anchor="t">
+          <a:bodyPr wrap="square" lIns="36576" tIns="36576" rIns="36576" bIns="36576" anchor="t">
             <a:spAutoFit/>
           </a:bodyPr>
           <a:lstStyle/>
@@ -6631,7 +7951,7 @@
           <a:noFill/>
         </p:spPr>
         <p:txBody>
-          <a:bodyPr wrap="square" lIns="36576" rIns="36576" tIns="36576" bIns="36576" anchor="t">
+          <a:bodyPr wrap="square" lIns="36576" tIns="36576" rIns="36576" bIns="36576" anchor="t">
             <a:spAutoFit/>
           </a:bodyPr>
           <a:lstStyle/>
@@ -6699,6 +8019,7 @@
           <a:lstStyle/>
           <a:p>
             <a:pPr algn="ctr"/>
+            <a:endParaRPr/>
           </a:p>
         </p:txBody>
       </p:sp>
@@ -6719,7 +8040,7 @@
           <a:noFill/>
         </p:spPr>
         <p:txBody>
-          <a:bodyPr wrap="square" lIns="36576" rIns="36576" tIns="36576" bIns="36576" anchor="t">
+          <a:bodyPr wrap="square" lIns="36576" tIns="36576" rIns="36576" bIns="36576" anchor="t">
             <a:spAutoFit/>
           </a:bodyPr>
           <a:lstStyle/>
@@ -6758,7 +8079,7 @@
           <a:noFill/>
         </p:spPr>
         <p:txBody>
-          <a:bodyPr wrap="square" lIns="36576" rIns="36576" tIns="36576" bIns="36576" anchor="t">
+          <a:bodyPr wrap="square" lIns="36576" tIns="36576" rIns="36576" bIns="36576" anchor="t">
             <a:spAutoFit/>
           </a:bodyPr>
           <a:lstStyle/>
@@ -6797,7 +8118,7 @@
           <a:noFill/>
         </p:spPr>
         <p:txBody>
-          <a:bodyPr wrap="square" lIns="36576" rIns="36576" tIns="36576" bIns="36576" anchor="t">
+          <a:bodyPr wrap="square" lIns="36576" tIns="36576" rIns="36576" bIns="36576" anchor="t">
             <a:spAutoFit/>
           </a:bodyPr>
           <a:lstStyle/>
@@ -6828,15 +8149,15 @@
           <p:nvPr/>
         </p:nvPicPr>
         <p:blipFill>
-          <a:blip r:embed="rId2"/>
+          <a:blip r:embed="rId3"/>
           <a:stretch>
             <a:fillRect/>
           </a:stretch>
         </p:blipFill>
         <p:spPr>
           <a:xfrm>
-            <a:off x="1851183" y="1783080"/>
-            <a:ext cx="2332672" cy="4251960"/>
+            <a:off x="1965959" y="1783080"/>
+            <a:ext cx="2103120" cy="3611880"/>
           </a:xfrm>
           <a:prstGeom prst="rect">
             <a:avLst/>
@@ -6851,8 +8172,8 @@
         </p:nvSpPr>
         <p:spPr>
           <a:xfrm>
-            <a:off x="1851183" y="1783080"/>
-            <a:ext cx="2332672" cy="4251960"/>
+            <a:off x="1965959" y="1783080"/>
+            <a:ext cx="2103120" cy="3611880"/>
           </a:xfrm>
           <a:prstGeom prst="roundRect">
             <a:avLst/>
@@ -6883,6 +8204,7 @@
           <a:lstStyle/>
           <a:p>
             <a:pPr algn="ctr"/>
+            <a:endParaRPr/>
           </a:p>
         </p:txBody>
       </p:sp>
@@ -6903,7 +8225,7 @@
           <a:noFill/>
         </p:spPr>
         <p:txBody>
-          <a:bodyPr wrap="square" lIns="36576" rIns="36576" tIns="36576" bIns="36576" anchor="t">
+          <a:bodyPr wrap="square" lIns="36576" tIns="36576" rIns="36576" bIns="36576" anchor="t">
             <a:spAutoFit/>
           </a:bodyPr>
           <a:lstStyle/>
@@ -6933,8 +8255,8 @@
         </p:nvSpPr>
         <p:spPr>
           <a:xfrm>
-            <a:off x="7246143" y="1783080"/>
-            <a:ext cx="2332672" cy="4251960"/>
+            <a:off x="7246143" y="5605272"/>
+            <a:ext cx="2332672" cy="713232"/>
           </a:xfrm>
           <a:prstGeom prst="roundRect">
             <a:avLst/>
@@ -6965,6 +8287,7 @@
           <a:lstStyle/>
           <a:p>
             <a:pPr algn="ctr"/>
+            <a:endParaRPr/>
           </a:p>
         </p:txBody>
       </p:sp>
@@ -6976,8 +8299,8 @@
         </p:nvSpPr>
         <p:spPr>
           <a:xfrm>
-            <a:off x="1828800" y="5715000"/>
-            <a:ext cx="8549640" cy="594360"/>
+            <a:off x="1828800" y="5559552"/>
+            <a:ext cx="8549640" cy="694944"/>
           </a:xfrm>
           <a:prstGeom prst="roundRect">
             <a:avLst/>
@@ -7010,6 +8333,7 @@
           <a:lstStyle/>
           <a:p>
             <a:pPr algn="ctr"/>
+            <a:endParaRPr/>
           </a:p>
         </p:txBody>
       </p:sp>
@@ -7021,8 +8345,8 @@
         </p:nvSpPr>
         <p:spPr>
           <a:xfrm>
-            <a:off x="1828800" y="5715000"/>
-            <a:ext cx="54864" cy="594360"/>
+            <a:off x="1828800" y="5559552"/>
+            <a:ext cx="54864" cy="694944"/>
           </a:xfrm>
           <a:prstGeom prst="rect">
             <a:avLst/>
@@ -7053,6 +8377,7 @@
           <a:lstStyle/>
           <a:p>
             <a:pPr algn="ctr"/>
+            <a:endParaRPr/>
           </a:p>
         </p:txBody>
       </p:sp>
@@ -7064,8 +8389,8 @@
         </p:nvSpPr>
         <p:spPr>
           <a:xfrm>
-            <a:off x="2011680" y="5852160"/>
-            <a:ext cx="8229600" cy="274320"/>
+            <a:off x="2011680" y="5680540"/>
+            <a:ext cx="8138160" cy="184666"/>
           </a:xfrm>
           <a:prstGeom prst="rect">
             <a:avLst/>
@@ -7073,7 +8398,7 @@
           <a:noFill/>
         </p:spPr>
         <p:txBody>
-          <a:bodyPr wrap="square" lIns="36576" rIns="36576" tIns="36576" bIns="36576" anchor="t">
+          <a:bodyPr wrap="square" lIns="0" tIns="0" rIns="0" bIns="0" anchor="ctr">
             <a:spAutoFit/>
           </a:bodyPr>
           <a:lstStyle/>
@@ -7082,14 +8407,19 @@
               <a:spcAft>
                 <a:spcPts val="500"/>
               </a:spcAft>
-              <a:defRPr sz="1500" b="1">
-                <a:solidFill>
-                  <a:srgbClr val="F8FAFD"/>
+              <a:defRPr sz="1200" b="1">
+                <a:solidFill>
+                  <a:srgbClr val="22583B"/>
                 </a:solidFill>
                 <a:latin typeface="Aptos"/>
               </a:defRPr>
             </a:pPr>
             <a:r>
+              <a:rPr dirty="0">
+                <a:solidFill>
+                  <a:srgbClr val="92D050"/>
+                </a:solidFill>
+              </a:rPr>
               <a:t>What changed</a:t>
             </a:r>
           </a:p>
@@ -7103,8 +8433,8 @@
         </p:nvSpPr>
         <p:spPr>
           <a:xfrm>
-            <a:off x="2011680" y="6217920"/>
-            <a:ext cx="8202167" cy="0"/>
+            <a:off x="2029968" y="5947502"/>
+            <a:ext cx="8138160" cy="138499"/>
           </a:xfrm>
           <a:prstGeom prst="rect">
             <a:avLst/>
@@ -7112,7 +8442,7 @@
           <a:noFill/>
         </p:spPr>
         <p:txBody>
-          <a:bodyPr wrap="square" lIns="36576" rIns="36576" tIns="36576" bIns="36576" anchor="t">
+          <a:bodyPr wrap="square" lIns="0" tIns="0" rIns="0" bIns="0" anchor="ctr">
             <a:spAutoFit/>
           </a:bodyPr>
           <a:lstStyle/>
@@ -7121,21 +8451,20 @@
               <a:spcAft>
                 <a:spcPts val="500"/>
               </a:spcAft>
-              <a:defRPr sz="1100" b="0">
-                <a:solidFill>
-                  <a:srgbClr val="E0EAF6"/>
+              <a:defRPr sz="900" b="0">
+                <a:solidFill>
+                  <a:srgbClr val="465049"/>
                 </a:solidFill>
                 <a:latin typeface="Aptos"/>
               </a:defRPr>
             </a:pPr>
             <a:r>
-              <a:rPr sz="900">
-                <a:solidFill>
-                  <a:srgbClr val="E0EAF6"/>
-                </a:solidFill>
-                <a:latin typeface="Aptos"/>
+              <a:rPr dirty="0">
+                <a:solidFill>
+                  <a:schemeClr val="bg1"/>
+                </a:solidFill>
               </a:rPr>
-              <a:t>The redesigned cart now highlights collection point, quantity controls, subtotal, 5% GST, total, and a clear Continue action. Existing backend order/payment logic remains unchanged.</a:t>
+              <a:t>The cart groups collection details, quantity controls, subtotal, 5% GST, total, and Continue. Existing order and payment logic remains in use.</a:t>
             </a:r>
           </a:p>
         </p:txBody>
@@ -7156,8 +8485,8 @@
         </p:blipFill>
         <p:spPr>
           <a:xfrm>
-            <a:off x="7246143" y="1783080"/>
-            <a:ext cx="2332672" cy="4251960"/>
+            <a:off x="7375113" y="1737360"/>
+            <a:ext cx="2038158" cy="3566160"/>
           </a:xfrm>
           <a:prstGeom prst="rect">
             <a:avLst/>
@@ -7169,11 +8498,23 @@
   <p:clrMapOvr>
     <a:masterClrMapping/>
   </p:clrMapOvr>
+  <mc:AlternateContent xmlns:mc="http://schemas.openxmlformats.org/markup-compatibility/2006" xmlns:p14="http://schemas.microsoft.com/office/powerpoint/2010/main">
+    <mc:Choice Requires="p14">
+      <p:transition spd="med" p14:dur="700">
+        <p:fade/>
+      </p:transition>
+    </mc:Choice>
+    <mc:Fallback xmlns="">
+      <p:transition spd="med">
+        <p:fade/>
+      </p:transition>
+    </mc:Fallback>
+  </mc:AlternateContent>
 </p:sld>
 </file>
 
-<file path=ppt/slides/slide8.xml><?xml version="1.0" encoding="utf-8"?>
-<p:sld xmlns:a="http://schemas.openxmlformats.org/drawingml/2006/main" xmlns:p="http://schemas.openxmlformats.org/presentationml/2006/main" xmlns:r="http://schemas.openxmlformats.org/officeDocument/2006/relationships">
+<file path=ppt/slides/slide7.xml><?xml version="1.0" encoding="utf-8"?>
+<p:sld xmlns:a="http://schemas.openxmlformats.org/drawingml/2006/main" xmlns:r="http://schemas.openxmlformats.org/officeDocument/2006/relationships" xmlns:p="http://schemas.openxmlformats.org/presentationml/2006/main">
   <p:cSld>
     <p:bg>
       <p:bgPr>
@@ -7189,7 +8530,14 @@
         <p:cNvGrpSpPr/>
         <p:nvPr/>
       </p:nvGrpSpPr>
-      <p:grpSpPr/>
+      <p:grpSpPr>
+        <a:xfrm>
+          <a:off x="0" y="0"/>
+          <a:ext cx="0" cy="0"/>
+          <a:chOff x="0" y="0"/>
+          <a:chExt cx="0" cy="0"/>
+        </a:xfrm>
+      </p:grpSpPr>
       <p:sp>
         <p:nvSpPr>
           <p:cNvPr id="2" name="TextBox 1"/>
@@ -7207,7 +8555,7 @@
           <a:noFill/>
         </p:spPr>
         <p:txBody>
-          <a:bodyPr wrap="square" lIns="36576" rIns="36576" tIns="36576" bIns="36576" anchor="t">
+          <a:bodyPr wrap="square" lIns="36576" tIns="36576" rIns="36576" bIns="36576" anchor="t">
             <a:spAutoFit/>
           </a:bodyPr>
           <a:lstStyle/>
@@ -7246,7 +8594,7 @@
           <a:noFill/>
         </p:spPr>
         <p:txBody>
-          <a:bodyPr wrap="square" lIns="36576" rIns="36576" tIns="36576" bIns="36576" anchor="t">
+          <a:bodyPr wrap="square" lIns="36576" tIns="36576" rIns="36576" bIns="36576" anchor="t">
             <a:spAutoFit/>
           </a:bodyPr>
           <a:lstStyle/>
@@ -7308,6 +8656,7 @@
           <a:lstStyle/>
           <a:p>
             <a:pPr algn="ctr"/>
+            <a:endParaRPr/>
           </a:p>
         </p:txBody>
       </p:sp>
@@ -7328,7 +8677,7 @@
           <a:noFill/>
         </p:spPr>
         <p:txBody>
-          <a:bodyPr wrap="square" lIns="36576" rIns="36576" tIns="36576" bIns="36576" anchor="t">
+          <a:bodyPr wrap="square" lIns="36576" tIns="36576" rIns="36576" bIns="36576" anchor="t">
             <a:spAutoFit/>
           </a:bodyPr>
           <a:lstStyle/>
@@ -7367,7 +8716,7 @@
           <a:noFill/>
         </p:spPr>
         <p:txBody>
-          <a:bodyPr wrap="square" lIns="36576" rIns="36576" tIns="36576" bIns="36576" anchor="t">
+          <a:bodyPr wrap="square" lIns="36576" tIns="36576" rIns="36576" bIns="36576" anchor="t">
             <a:spAutoFit/>
           </a:bodyPr>
           <a:lstStyle/>
@@ -7389,30 +8738,6 @@
           </a:p>
         </p:txBody>
       </p:sp>
-      <p:pic>
-        <p:nvPicPr>
-          <p:cNvPr id="7" name="Picture 6" descr="new_profile.png"/>
-          <p:cNvPicPr>
-            <a:picLocks noChangeAspect="1"/>
-          </p:cNvPicPr>
-          <p:nvPr/>
-        </p:nvPicPr>
-        <p:blipFill>
-          <a:blip r:embed="rId2"/>
-          <a:stretch>
-            <a:fillRect/>
-          </a:stretch>
-        </p:blipFill>
-        <p:spPr>
-          <a:xfrm>
-            <a:off x="1005840" y="1508760"/>
-            <a:ext cx="3291840" cy="6000315"/>
-          </a:xfrm>
-          <a:prstGeom prst="rect">
-            <a:avLst/>
-          </a:prstGeom>
-        </p:spPr>
-      </p:pic>
       <p:sp>
         <p:nvSpPr>
           <p:cNvPr id="8" name="Rounded Rectangle 7"/>
@@ -7455,6 +8780,7 @@
           <a:lstStyle/>
           <a:p>
             <a:pPr algn="ctr"/>
+            <a:endParaRPr/>
           </a:p>
         </p:txBody>
       </p:sp>
@@ -7498,6 +8824,7 @@
           <a:lstStyle/>
           <a:p>
             <a:pPr algn="ctr"/>
+            <a:endParaRPr/>
           </a:p>
         </p:txBody>
       </p:sp>
@@ -7509,8 +8836,8 @@
         </p:nvSpPr>
         <p:spPr>
           <a:xfrm>
-            <a:off x="4937760" y="1965960"/>
-            <a:ext cx="5623560" cy="274320"/>
+            <a:off x="4928616" y="2179379"/>
+            <a:ext cx="5623560" cy="184666"/>
           </a:xfrm>
           <a:prstGeom prst="rect">
             <a:avLst/>
@@ -7518,7 +8845,7 @@
           <a:noFill/>
         </p:spPr>
         <p:txBody>
-          <a:bodyPr wrap="square" lIns="36576" rIns="36576" tIns="36576" bIns="36576" anchor="t">
+          <a:bodyPr wrap="square" lIns="0" tIns="0" rIns="0" bIns="0" anchor="ctr">
             <a:spAutoFit/>
           </a:bodyPr>
           <a:lstStyle/>
@@ -7527,14 +8854,19 @@
               <a:spcAft>
                 <a:spcPts val="500"/>
               </a:spcAft>
-              <a:defRPr sz="1500" b="1">
-                <a:solidFill>
-                  <a:srgbClr val="F8FAFD"/>
+              <a:defRPr sz="1200" b="1">
+                <a:solidFill>
+                  <a:srgbClr val="22583B"/>
                 </a:solidFill>
                 <a:latin typeface="Aptos"/>
               </a:defRPr>
             </a:pPr>
             <a:r>
+              <a:rPr dirty="0">
+                <a:solidFill>
+                  <a:schemeClr val="accent3"/>
+                </a:solidFill>
+              </a:rPr>
               <a:t>Profile details</a:t>
             </a:r>
           </a:p>
@@ -7548,8 +8880,8 @@
         </p:nvSpPr>
         <p:spPr>
           <a:xfrm>
-            <a:off x="4937760" y="2331720"/>
-            <a:ext cx="5596128" cy="594360"/>
+            <a:off x="4928616" y="2423160"/>
+            <a:ext cx="5596128" cy="153888"/>
           </a:xfrm>
           <a:prstGeom prst="rect">
             <a:avLst/>
@@ -7557,7 +8889,7 @@
           <a:noFill/>
         </p:spPr>
         <p:txBody>
-          <a:bodyPr wrap="square" lIns="36576" rIns="36576" tIns="36576" bIns="36576" anchor="t">
+          <a:bodyPr wrap="square" lIns="0" tIns="0" rIns="0" bIns="0" anchor="ctr">
             <a:spAutoFit/>
           </a:bodyPr>
           <a:lstStyle/>
@@ -7566,15 +8898,20 @@
               <a:spcAft>
                 <a:spcPts val="500"/>
               </a:spcAft>
-              <a:defRPr sz="1400" b="0">
-                <a:solidFill>
-                  <a:srgbClr val="E0EAF6"/>
+              <a:defRPr sz="1000" b="0">
+                <a:solidFill>
+                  <a:srgbClr val="465049"/>
                 </a:solidFill>
                 <a:latin typeface="Aptos"/>
               </a:defRPr>
             </a:pPr>
             <a:r>
-              <a:t>Displays customer name and email, with a profile save action.</a:t>
+              <a:rPr dirty="0">
+                <a:solidFill>
+                  <a:schemeClr val="bg1"/>
+                </a:solidFill>
+              </a:rPr>
+              <a:t>Shows the registered customer name and email in read-only fields.</a:t>
             </a:r>
           </a:p>
         </p:txBody>
@@ -7621,6 +8958,7 @@
           <a:lstStyle/>
           <a:p>
             <a:pPr algn="ctr"/>
+            <a:endParaRPr/>
           </a:p>
         </p:txBody>
       </p:sp>
@@ -7664,6 +9002,7 @@
           <a:lstStyle/>
           <a:p>
             <a:pPr algn="ctr"/>
+            <a:endParaRPr/>
           </a:p>
         </p:txBody>
       </p:sp>
@@ -7675,8 +9014,8 @@
         </p:nvSpPr>
         <p:spPr>
           <a:xfrm>
-            <a:off x="4937760" y="3383279"/>
-            <a:ext cx="5623560" cy="274320"/>
+            <a:off x="4937760" y="3591806"/>
+            <a:ext cx="5623560" cy="184666"/>
           </a:xfrm>
           <a:prstGeom prst="rect">
             <a:avLst/>
@@ -7684,7 +9023,7 @@
           <a:noFill/>
         </p:spPr>
         <p:txBody>
-          <a:bodyPr wrap="square" lIns="36576" rIns="36576" tIns="36576" bIns="36576" anchor="t">
+          <a:bodyPr wrap="square" lIns="0" tIns="0" rIns="0" bIns="0" anchor="ctr">
             <a:spAutoFit/>
           </a:bodyPr>
           <a:lstStyle/>
@@ -7693,14 +9032,19 @@
               <a:spcAft>
                 <a:spcPts val="500"/>
               </a:spcAft>
-              <a:defRPr sz="1500" b="1">
-                <a:solidFill>
-                  <a:srgbClr val="F8FAFD"/>
+              <a:defRPr sz="1200" b="1">
+                <a:solidFill>
+                  <a:srgbClr val="22583B"/>
                 </a:solidFill>
                 <a:latin typeface="Aptos"/>
               </a:defRPr>
             </a:pPr>
             <a:r>
+              <a:rPr dirty="0">
+                <a:solidFill>
+                  <a:schemeClr val="accent3"/>
+                </a:solidFill>
+              </a:rPr>
               <a:t>Account navigation</a:t>
             </a:r>
           </a:p>
@@ -7714,8 +9058,8 @@
         </p:nvSpPr>
         <p:spPr>
           <a:xfrm>
-            <a:off x="4937760" y="3749039"/>
-            <a:ext cx="5596128" cy="594360"/>
+            <a:off x="4928616" y="3840480"/>
+            <a:ext cx="5596128" cy="153888"/>
           </a:xfrm>
           <a:prstGeom prst="rect">
             <a:avLst/>
@@ -7723,7 +9067,7 @@
           <a:noFill/>
         </p:spPr>
         <p:txBody>
-          <a:bodyPr wrap="square" lIns="36576" rIns="36576" tIns="36576" bIns="36576" anchor="t">
+          <a:bodyPr wrap="square" lIns="0" tIns="0" rIns="0" bIns="0" anchor="ctr">
             <a:spAutoFit/>
           </a:bodyPr>
           <a:lstStyle/>
@@ -7732,15 +9076,20 @@
               <a:spcAft>
                 <a:spcPts val="500"/>
               </a:spcAft>
-              <a:defRPr sz="1400" b="0">
-                <a:solidFill>
-                  <a:srgbClr val="E0EAF6"/>
+              <a:defRPr sz="1000" b="0">
+                <a:solidFill>
+                  <a:srgbClr val="465049"/>
                 </a:solidFill>
                 <a:latin typeface="Aptos"/>
               </a:defRPr>
             </a:pPr>
             <a:r>
-              <a:t>Provides access to saved orders and sign-out from the account screen.</a:t>
+              <a:rPr dirty="0">
+                <a:solidFill>
+                  <a:schemeClr val="bg1"/>
+                </a:solidFill>
+              </a:rPr>
+              <a:t>Provides access to saved orders and sign-out from the Juice Robo account.</a:t>
             </a:r>
           </a:p>
         </p:txBody>
@@ -7762,7 +9111,7 @@
           <a:noFill/>
         </p:spPr>
         <p:txBody>
-          <a:bodyPr wrap="square" lIns="36576" rIns="36576" tIns="36576" bIns="36576" anchor="t">
+          <a:bodyPr wrap="square" lIns="0" tIns="0" rIns="0" bIns="0" anchor="ctr">
             <a:spAutoFit/>
           </a:bodyPr>
           <a:lstStyle/>
@@ -7771,29 +9120,65 @@
               <a:spcAft>
                 <a:spcPts val="500"/>
               </a:spcAft>
-              <a:defRPr sz="1400" b="0">
-                <a:solidFill>
-                  <a:srgbClr val="E0EAF6"/>
+              <a:defRPr sz="1000" b="0">
+                <a:solidFill>
+                  <a:srgbClr val="465049"/>
                 </a:solidFill>
                 <a:latin typeface="Aptos"/>
               </a:defRPr>
             </a:pPr>
             <a:r>
-              <a:t>Integration check: confirm profile data and save actions use the existing supported account APIs and session flow.</a:t>
-            </a:r>
-          </a:p>
-        </p:txBody>
-      </p:sp>
+              <a:t>Profile data is displayed as read-only. The screen also links to saved orders and sign-out.</a:t>
+            </a:r>
+          </a:p>
+        </p:txBody>
+      </p:sp>
+      <p:pic>
+        <p:nvPicPr>
+          <p:cNvPr id="17" name="Picture 16" descr="WhatsApp Image 2026-10-26 at 11.15.56 AM.jpeg"/>
+          <p:cNvPicPr>
+            <a:picLocks noChangeAspect="1"/>
+          </p:cNvPicPr>
+          <p:nvPr/>
+        </p:nvPicPr>
+        <p:blipFill>
+          <a:blip r:embed="rId3"/>
+          <a:stretch>
+            <a:fillRect/>
+          </a:stretch>
+        </p:blipFill>
+        <p:spPr>
+          <a:xfrm>
+            <a:off x="1543496" y="1508760"/>
+            <a:ext cx="2216527" cy="4800600"/>
+          </a:xfrm>
+          <a:prstGeom prst="rect">
+            <a:avLst/>
+          </a:prstGeom>
+        </p:spPr>
+      </p:pic>
     </p:spTree>
   </p:cSld>
   <p:clrMapOvr>
     <a:masterClrMapping/>
   </p:clrMapOvr>
+  <mc:AlternateContent xmlns:mc="http://schemas.openxmlformats.org/markup-compatibility/2006" xmlns:p14="http://schemas.microsoft.com/office/powerpoint/2010/main">
+    <mc:Choice Requires="p14">
+      <p:transition spd="med" p14:dur="700">
+        <p:fade/>
+      </p:transition>
+    </mc:Choice>
+    <mc:Fallback xmlns="">
+      <p:transition spd="med">
+        <p:fade/>
+      </p:transition>
+    </mc:Fallback>
+  </mc:AlternateContent>
 </p:sld>
 </file>
 
-<file path=ppt/slides/slide9.xml><?xml version="1.0" encoding="utf-8"?>
-<p:sld xmlns:a="http://schemas.openxmlformats.org/drawingml/2006/main" xmlns:p="http://schemas.openxmlformats.org/presentationml/2006/main" xmlns:r="http://schemas.openxmlformats.org/officeDocument/2006/relationships">
+<file path=ppt/slides/slide8.xml><?xml version="1.0" encoding="utf-8"?>
+<p:sld xmlns:a="http://schemas.openxmlformats.org/drawingml/2006/main" xmlns:r="http://schemas.openxmlformats.org/officeDocument/2006/relationships" xmlns:p="http://schemas.openxmlformats.org/presentationml/2006/main">
   <p:cSld>
     <p:bg>
       <p:bgPr>
@@ -7809,7 +9194,14 @@
         <p:cNvGrpSpPr/>
         <p:nvPr/>
       </p:nvGrpSpPr>
-      <p:grpSpPr/>
+      <p:grpSpPr>
+        <a:xfrm>
+          <a:off x="0" y="0"/>
+          <a:ext cx="0" cy="0"/>
+          <a:chOff x="0" y="0"/>
+          <a:chExt cx="0" cy="0"/>
+        </a:xfrm>
+      </p:grpSpPr>
       <p:sp>
         <p:nvSpPr>
           <p:cNvPr id="2" name="TextBox 1"/>
@@ -7827,7 +9219,7 @@
           <a:noFill/>
         </p:spPr>
         <p:txBody>
-          <a:bodyPr wrap="square" lIns="36576" rIns="36576" tIns="36576" bIns="36576" anchor="t">
+          <a:bodyPr wrap="square" lIns="36576" tIns="36576" rIns="36576" bIns="36576" anchor="t">
             <a:spAutoFit/>
           </a:bodyPr>
           <a:lstStyle/>
@@ -7866,7 +9258,7 @@
           <a:noFill/>
         </p:spPr>
         <p:txBody>
-          <a:bodyPr wrap="square" lIns="36576" rIns="36576" tIns="36576" bIns="36576" anchor="t">
+          <a:bodyPr wrap="square" lIns="36576" tIns="36576" rIns="36576" bIns="36576" anchor="t">
             <a:spAutoFit/>
           </a:bodyPr>
           <a:lstStyle/>
@@ -7928,6 +9320,7 @@
           <a:lstStyle/>
           <a:p>
             <a:pPr algn="ctr"/>
+            <a:endParaRPr/>
           </a:p>
         </p:txBody>
       </p:sp>
@@ -7948,7 +9341,7 @@
           <a:noFill/>
         </p:spPr>
         <p:txBody>
-          <a:bodyPr wrap="square" lIns="36576" rIns="36576" tIns="36576" bIns="36576" anchor="t">
+          <a:bodyPr wrap="square" lIns="36576" tIns="36576" rIns="36576" bIns="36576" anchor="t">
             <a:spAutoFit/>
           </a:bodyPr>
           <a:lstStyle/>
@@ -7987,7 +9380,7 @@
           <a:noFill/>
         </p:spPr>
         <p:txBody>
-          <a:bodyPr wrap="square" lIns="36576" rIns="36576" tIns="36576" bIns="36576" anchor="t">
+          <a:bodyPr wrap="square" lIns="36576" tIns="36576" rIns="36576" bIns="36576" anchor="t">
             <a:spAutoFit/>
           </a:bodyPr>
           <a:lstStyle/>
@@ -8049,6 +9442,7 @@
           <a:lstStyle/>
           <a:p>
             <a:pPr algn="ctr"/>
+            <a:endParaRPr/>
           </a:p>
         </p:txBody>
       </p:sp>
@@ -8069,7 +9463,7 @@
           <a:noFill/>
         </p:spPr>
         <p:txBody>
-          <a:bodyPr wrap="square" lIns="36576" rIns="36576" tIns="36576" bIns="36576" anchor="t">
+          <a:bodyPr wrap="square" lIns="36576" tIns="36576" rIns="36576" bIns="36576" anchor="t">
             <a:spAutoFit/>
           </a:bodyPr>
           <a:lstStyle/>
@@ -8108,7 +9502,7 @@
           <a:noFill/>
         </p:spPr>
         <p:txBody>
-          <a:bodyPr wrap="square" lIns="36576" rIns="36576" tIns="36576" bIns="36576" anchor="t">
+          <a:bodyPr wrap="square" lIns="36576" tIns="36576" rIns="36576" bIns="36576" anchor="t">
             <a:spAutoFit/>
           </a:bodyPr>
           <a:lstStyle/>
@@ -8170,6 +9564,7 @@
           <a:lstStyle/>
           <a:p>
             <a:pPr algn="ctr"/>
+            <a:endParaRPr/>
           </a:p>
         </p:txBody>
       </p:sp>
@@ -8190,7 +9585,7 @@
           <a:noFill/>
         </p:spPr>
         <p:txBody>
-          <a:bodyPr wrap="square" lIns="36576" rIns="36576" tIns="36576" bIns="36576" anchor="t">
+          <a:bodyPr wrap="square" lIns="36576" tIns="36576" rIns="36576" bIns="36576" anchor="t">
             <a:spAutoFit/>
           </a:bodyPr>
           <a:lstStyle/>
@@ -8229,7 +9624,7 @@
           <a:noFill/>
         </p:spPr>
         <p:txBody>
-          <a:bodyPr wrap="square" lIns="36576" rIns="36576" tIns="36576" bIns="36576" anchor="t">
+          <a:bodyPr wrap="square" lIns="36576" tIns="36576" rIns="36576" bIns="36576" anchor="t">
             <a:spAutoFit/>
           </a:bodyPr>
           <a:lstStyle/>
@@ -8291,6 +9686,7 @@
           <a:lstStyle/>
           <a:p>
             <a:pPr algn="ctr"/>
+            <a:endParaRPr/>
           </a:p>
         </p:txBody>
       </p:sp>
@@ -8311,7 +9707,7 @@
           <a:noFill/>
         </p:spPr>
         <p:txBody>
-          <a:bodyPr wrap="square" lIns="36576" rIns="36576" tIns="36576" bIns="36576" anchor="t">
+          <a:bodyPr wrap="square" lIns="36576" tIns="36576" rIns="36576" bIns="36576" anchor="t">
             <a:spAutoFit/>
           </a:bodyPr>
           <a:lstStyle/>
@@ -8350,7 +9746,7 @@
           <a:noFill/>
         </p:spPr>
         <p:txBody>
-          <a:bodyPr wrap="square" lIns="36576" rIns="36576" tIns="36576" bIns="36576" anchor="t">
+          <a:bodyPr wrap="square" lIns="36576" tIns="36576" rIns="36576" bIns="36576" anchor="t">
             <a:spAutoFit/>
           </a:bodyPr>
           <a:lstStyle/>
@@ -8412,6 +9808,7 @@
           <a:lstStyle/>
           <a:p>
             <a:pPr algn="ctr"/>
+            <a:endParaRPr/>
           </a:p>
         </p:txBody>
       </p:sp>
@@ -8432,7 +9829,7 @@
           <a:noFill/>
         </p:spPr>
         <p:txBody>
-          <a:bodyPr wrap="square" lIns="36576" rIns="36576" tIns="36576" bIns="36576" anchor="t">
+          <a:bodyPr wrap="square" lIns="36576" tIns="36576" rIns="36576" bIns="36576" anchor="t">
             <a:spAutoFit/>
           </a:bodyPr>
           <a:lstStyle/>
@@ -8471,7 +9868,7 @@
           <a:noFill/>
         </p:spPr>
         <p:txBody>
-          <a:bodyPr wrap="square" lIns="36576" rIns="36576" tIns="36576" bIns="36576" anchor="t">
+          <a:bodyPr wrap="square" lIns="36576" tIns="36576" rIns="36576" bIns="36576" anchor="t">
             <a:spAutoFit/>
           </a:bodyPr>
           <a:lstStyle/>
@@ -8640,6 +10037,7 @@
           <a:lstStyle/>
           <a:p>
             <a:pPr algn="ctr"/>
+            <a:endParaRPr/>
           </a:p>
         </p:txBody>
       </p:sp>
@@ -8683,6 +10081,7 @@
           <a:lstStyle/>
           <a:p>
             <a:pPr algn="ctr"/>
+            <a:endParaRPr/>
           </a:p>
         </p:txBody>
       </p:sp>
@@ -8703,7 +10102,7 @@
           <a:noFill/>
         </p:spPr>
         <p:txBody>
-          <a:bodyPr wrap="square" lIns="36576" rIns="36576" tIns="36576" bIns="36576" anchor="t">
+          <a:bodyPr wrap="square" lIns="36576" tIns="36576" rIns="36576" bIns="36576" anchor="t">
             <a:spAutoFit/>
           </a:bodyPr>
           <a:lstStyle/>
@@ -8742,7 +10141,7 @@
           <a:noFill/>
         </p:spPr>
         <p:txBody>
-          <a:bodyPr wrap="square" lIns="36576" rIns="36576" tIns="36576" bIns="36576" anchor="t">
+          <a:bodyPr wrap="square" lIns="36576" tIns="36576" rIns="36576" bIns="36576" anchor="t">
             <a:spAutoFit/>
           </a:bodyPr>
           <a:lstStyle/>
@@ -8806,6 +10205,7 @@
           <a:lstStyle/>
           <a:p>
             <a:pPr algn="ctr"/>
+            <a:endParaRPr/>
           </a:p>
         </p:txBody>
       </p:sp>
@@ -8849,6 +10249,7 @@
           <a:lstStyle/>
           <a:p>
             <a:pPr algn="ctr"/>
+            <a:endParaRPr/>
           </a:p>
         </p:txBody>
       </p:sp>
@@ -8869,7 +10270,7 @@
           <a:noFill/>
         </p:spPr>
         <p:txBody>
-          <a:bodyPr wrap="square" lIns="36576" rIns="36576" tIns="36576" bIns="36576" anchor="t">
+          <a:bodyPr wrap="square" lIns="36576" tIns="36576" rIns="36576" bIns="36576" anchor="t">
             <a:spAutoFit/>
           </a:bodyPr>
           <a:lstStyle/>
@@ -8908,7 +10309,7 @@
           <a:noFill/>
         </p:spPr>
         <p:txBody>
-          <a:bodyPr wrap="square" lIns="36576" rIns="36576" tIns="36576" bIns="36576" anchor="t">
+          <a:bodyPr wrap="square" lIns="36576" tIns="36576" rIns="36576" bIns="36576" anchor="t">
             <a:spAutoFit/>
           </a:bodyPr>
           <a:lstStyle/>
@@ -8947,7 +10348,7 @@
           <a:noFill/>
         </p:spPr>
         <p:txBody>
-          <a:bodyPr wrap="square" lIns="36576" rIns="36576" tIns="36576" bIns="36576" anchor="t">
+          <a:bodyPr wrap="square" lIns="36576" tIns="36576" rIns="36576" bIns="36576" anchor="t">
             <a:spAutoFit/>
           </a:bodyPr>
           <a:lstStyle/>
@@ -8974,6 +10375,18 @@
   <p:clrMapOvr>
     <a:masterClrMapping/>
   </p:clrMapOvr>
+  <mc:AlternateContent xmlns:mc="http://schemas.openxmlformats.org/markup-compatibility/2006" xmlns:p14="http://schemas.microsoft.com/office/powerpoint/2010/main">
+    <mc:Choice Requires="p14">
+      <p:transition spd="med" p14:dur="700">
+        <p:fade/>
+      </p:transition>
+    </mc:Choice>
+    <mc:Fallback xmlns="">
+      <p:transition spd="med">
+        <p:fade/>
+      </p:transition>
+    </mc:Fallback>
+  </mc:AlternateContent>
 </p:sld>
 </file>
 
@@ -9295,4 +10708,299 @@
   </a:objectDefaults>
   <a:extraClrSchemeLst/>
 </a:theme>
+</file>
+
+<file path=ppt/theme/theme2.xml><?xml version="1.0" encoding="utf-8"?>
+<a:theme xmlns:a="http://schemas.openxmlformats.org/drawingml/2006/main" name="Office Theme">
+  <a:themeElements>
+    <a:clrScheme name="Office">
+      <a:dk1>
+        <a:sysClr val="windowText" lastClr="000000"/>
+      </a:dk1>
+      <a:lt1>
+        <a:sysClr val="window" lastClr="FFFFFF"/>
+      </a:lt1>
+      <a:dk2>
+        <a:srgbClr val="44546A"/>
+      </a:dk2>
+      <a:lt2>
+        <a:srgbClr val="E7E6E6"/>
+      </a:lt2>
+      <a:accent1>
+        <a:srgbClr val="4472C4"/>
+      </a:accent1>
+      <a:accent2>
+        <a:srgbClr val="ED7D31"/>
+      </a:accent2>
+      <a:accent3>
+        <a:srgbClr val="A5A5A5"/>
+      </a:accent3>
+      <a:accent4>
+        <a:srgbClr val="FFC000"/>
+      </a:accent4>
+      <a:accent5>
+        <a:srgbClr val="5B9BD5"/>
+      </a:accent5>
+      <a:accent6>
+        <a:srgbClr val="70AD47"/>
+      </a:accent6>
+      <a:hlink>
+        <a:srgbClr val="0563C1"/>
+      </a:hlink>
+      <a:folHlink>
+        <a:srgbClr val="954F72"/>
+      </a:folHlink>
+    </a:clrScheme>
+    <a:fontScheme name="Office">
+      <a:majorFont>
+        <a:latin typeface="Calibri Light" panose="020F0302020204030204"/>
+        <a:ea typeface=""/>
+        <a:cs typeface=""/>
+        <a:font script="Jpan" typeface="游ゴシック Light"/>
+        <a:font script="Hang" typeface="맑은 고딕"/>
+        <a:font script="Hans" typeface="等线 Light"/>
+        <a:font script="Hant" typeface="新細明體"/>
+        <a:font script="Arab" typeface="Times New Roman"/>
+        <a:font script="Hebr" typeface="Times New Roman"/>
+        <a:font script="Thai" typeface="Angsana New"/>
+        <a:font script="Ethi" typeface="Nyala"/>
+        <a:font script="Beng" typeface="Vrinda"/>
+        <a:font script="Gujr" typeface="Shruti"/>
+        <a:font script="Khmr" typeface="MoolBoran"/>
+        <a:font script="Knda" typeface="Tunga"/>
+        <a:font script="Guru" typeface="Raavi"/>
+        <a:font script="Cans" typeface="Euphemia"/>
+        <a:font script="Cher" typeface="Plantagenet Cherokee"/>
+        <a:font script="Yiii" typeface="Microsoft Yi Baiti"/>
+        <a:font script="Tibt" typeface="Microsoft Himalaya"/>
+        <a:font script="Thaa" typeface="MV Boli"/>
+        <a:font script="Deva" typeface="Mangal"/>
+        <a:font script="Telu" typeface="Gautami"/>
+        <a:font script="Taml" typeface="Latha"/>
+        <a:font script="Syrc" typeface="Estrangelo Edessa"/>
+        <a:font script="Orya" typeface="Kalinga"/>
+        <a:font script="Mlym" typeface="Kartika"/>
+        <a:font script="Laoo" typeface="DokChampa"/>
+        <a:font script="Sinh" typeface="Iskoola Pota"/>
+        <a:font script="Mong" typeface="Mongolian Baiti"/>
+        <a:font script="Viet" typeface="Times New Roman"/>
+        <a:font script="Uigh" typeface="Microsoft Uighur"/>
+        <a:font script="Geor" typeface="Sylfaen"/>
+        <a:font script="Armn" typeface="Arial"/>
+        <a:font script="Bugi" typeface="Leelawadee UI"/>
+        <a:font script="Bopo" typeface="Microsoft JhengHei"/>
+        <a:font script="Java" typeface="Javanese Text"/>
+        <a:font script="Lisu" typeface="Segoe UI"/>
+        <a:font script="Mymr" typeface="Myanmar Text"/>
+        <a:font script="Nkoo" typeface="Ebrima"/>
+        <a:font script="Olck" typeface="Nirmala UI"/>
+        <a:font script="Osma" typeface="Ebrima"/>
+        <a:font script="Phag" typeface="Phagspa"/>
+        <a:font script="Syrn" typeface="Estrangelo Edessa"/>
+        <a:font script="Syrj" typeface="Estrangelo Edessa"/>
+        <a:font script="Syre" typeface="Estrangelo Edessa"/>
+        <a:font script="Sora" typeface="Nirmala UI"/>
+        <a:font script="Tale" typeface="Microsoft Tai Le"/>
+        <a:font script="Talu" typeface="Microsoft New Tai Lue"/>
+        <a:font script="Tfng" typeface="Ebrima"/>
+      </a:majorFont>
+      <a:minorFont>
+        <a:latin typeface="Calibri" panose="020F0502020204030204"/>
+        <a:ea typeface=""/>
+        <a:cs typeface=""/>
+        <a:font script="Jpan" typeface="游ゴシック"/>
+        <a:font script="Hang" typeface="맑은 고딕"/>
+        <a:font script="Hans" typeface="等线"/>
+        <a:font script="Hant" typeface="新細明體"/>
+        <a:font script="Arab" typeface="Arial"/>
+        <a:font script="Hebr" typeface="Arial"/>
+        <a:font script="Thai" typeface="Cordia New"/>
+        <a:font script="Ethi" typeface="Nyala"/>
+        <a:font script="Beng" typeface="Vrinda"/>
+        <a:font script="Gujr" typeface="Shruti"/>
+        <a:font script="Khmr" typeface="DaunPenh"/>
+        <a:font script="Knda" typeface="Tunga"/>
+        <a:font script="Guru" typeface="Raavi"/>
+        <a:font script="Cans" typeface="Euphemia"/>
+        <a:font script="Cher" typeface="Plantagenet Cherokee"/>
+        <a:font script="Yiii" typeface="Microsoft Yi Baiti"/>
+        <a:font script="Tibt" typeface="Microsoft Himalaya"/>
+        <a:font script="Thaa" typeface="MV Boli"/>
+        <a:font script="Deva" typeface="Mangal"/>
+        <a:font script="Telu" typeface="Gautami"/>
+        <a:font script="Taml" typeface="Latha"/>
+        <a:font script="Syrc" typeface="Estrangelo Edessa"/>
+        <a:font script="Orya" typeface="Kalinga"/>
+        <a:font script="Mlym" typeface="Kartika"/>
+        <a:font script="Laoo" typeface="DokChampa"/>
+        <a:font script="Sinh" typeface="Iskoola Pota"/>
+        <a:font script="Mong" typeface="Mongolian Baiti"/>
+        <a:font script="Viet" typeface="Arial"/>
+        <a:font script="Uigh" typeface="Microsoft Uighur"/>
+        <a:font script="Geor" typeface="Sylfaen"/>
+        <a:font script="Armn" typeface="Arial"/>
+        <a:font script="Bugi" typeface="Leelawadee UI"/>
+        <a:font script="Bopo" typeface="Microsoft JhengHei"/>
+        <a:font script="Java" typeface="Javanese Text"/>
+        <a:font script="Lisu" typeface="Segoe UI"/>
+        <a:font script="Mymr" typeface="Myanmar Text"/>
+        <a:font script="Nkoo" typeface="Ebrima"/>
+        <a:font script="Olck" typeface="Nirmala UI"/>
+        <a:font script="Osma" typeface="Ebrima"/>
+        <a:font script="Phag" typeface="Phagspa"/>
+        <a:font script="Syrn" typeface="Estrangelo Edessa"/>
+        <a:font script="Syrj" typeface="Estrangelo Edessa"/>
+        <a:font script="Syre" typeface="Estrangelo Edessa"/>
+        <a:font script="Sora" typeface="Nirmala UI"/>
+        <a:font script="Tale" typeface="Microsoft Tai Le"/>
+        <a:font script="Talu" typeface="Microsoft New Tai Lue"/>
+        <a:font script="Tfng" typeface="Ebrima"/>
+      </a:minorFont>
+    </a:fontScheme>
+    <a:fmtScheme name="Office">
+      <a:fillStyleLst>
+        <a:solidFill>
+          <a:schemeClr val="phClr"/>
+        </a:solidFill>
+        <a:gradFill rotWithShape="1">
+          <a:gsLst>
+            <a:gs pos="0">
+              <a:schemeClr val="phClr">
+                <a:lumMod val="110000"/>
+                <a:satMod val="105000"/>
+                <a:tint val="67000"/>
+              </a:schemeClr>
+            </a:gs>
+            <a:gs pos="50000">
+              <a:schemeClr val="phClr">
+                <a:lumMod val="105000"/>
+                <a:satMod val="103000"/>
+                <a:tint val="73000"/>
+              </a:schemeClr>
+            </a:gs>
+            <a:gs pos="100000">
+              <a:schemeClr val="phClr">
+                <a:lumMod val="105000"/>
+                <a:satMod val="109000"/>
+                <a:tint val="81000"/>
+              </a:schemeClr>
+            </a:gs>
+          </a:gsLst>
+          <a:lin ang="5400000" scaled="0"/>
+        </a:gradFill>
+        <a:gradFill rotWithShape="1">
+          <a:gsLst>
+            <a:gs pos="0">
+              <a:schemeClr val="phClr">
+                <a:satMod val="103000"/>
+                <a:lumMod val="102000"/>
+                <a:tint val="94000"/>
+              </a:schemeClr>
+            </a:gs>
+            <a:gs pos="50000">
+              <a:schemeClr val="phClr">
+                <a:satMod val="110000"/>
+                <a:lumMod val="100000"/>
+                <a:shade val="100000"/>
+              </a:schemeClr>
+            </a:gs>
+            <a:gs pos="100000">
+              <a:schemeClr val="phClr">
+                <a:lumMod val="99000"/>
+                <a:satMod val="120000"/>
+                <a:shade val="78000"/>
+              </a:schemeClr>
+            </a:gs>
+          </a:gsLst>
+          <a:lin ang="5400000" scaled="0"/>
+        </a:gradFill>
+      </a:fillStyleLst>
+      <a:lnStyleLst>
+        <a:ln w="6350" cap="flat" cmpd="sng" algn="ctr">
+          <a:solidFill>
+            <a:schemeClr val="phClr"/>
+          </a:solidFill>
+          <a:prstDash val="solid"/>
+          <a:miter lim="800000"/>
+        </a:ln>
+        <a:ln w="12700" cap="flat" cmpd="sng" algn="ctr">
+          <a:solidFill>
+            <a:schemeClr val="phClr"/>
+          </a:solidFill>
+          <a:prstDash val="solid"/>
+          <a:miter lim="800000"/>
+        </a:ln>
+        <a:ln w="19050" cap="flat" cmpd="sng" algn="ctr">
+          <a:solidFill>
+            <a:schemeClr val="phClr"/>
+          </a:solidFill>
+          <a:prstDash val="solid"/>
+          <a:miter lim="800000"/>
+        </a:ln>
+      </a:lnStyleLst>
+      <a:effectStyleLst>
+        <a:effectStyle>
+          <a:effectLst/>
+        </a:effectStyle>
+        <a:effectStyle>
+          <a:effectLst/>
+        </a:effectStyle>
+        <a:effectStyle>
+          <a:effectLst>
+            <a:outerShdw blurRad="57150" dist="19050" dir="5400000" algn="ctr" rotWithShape="0">
+              <a:srgbClr val="000000">
+                <a:alpha val="63000"/>
+              </a:srgbClr>
+            </a:outerShdw>
+          </a:effectLst>
+        </a:effectStyle>
+      </a:effectStyleLst>
+      <a:bgFillStyleLst>
+        <a:solidFill>
+          <a:schemeClr val="phClr"/>
+        </a:solidFill>
+        <a:solidFill>
+          <a:schemeClr val="phClr">
+            <a:tint val="95000"/>
+            <a:satMod val="170000"/>
+          </a:schemeClr>
+        </a:solidFill>
+        <a:gradFill rotWithShape="1">
+          <a:gsLst>
+            <a:gs pos="0">
+              <a:schemeClr val="phClr">
+                <a:tint val="93000"/>
+                <a:satMod val="150000"/>
+                <a:shade val="98000"/>
+                <a:lumMod val="102000"/>
+              </a:schemeClr>
+            </a:gs>
+            <a:gs pos="50000">
+              <a:schemeClr val="phClr">
+                <a:tint val="98000"/>
+                <a:satMod val="130000"/>
+                <a:shade val="90000"/>
+                <a:lumMod val="103000"/>
+              </a:schemeClr>
+            </a:gs>
+            <a:gs pos="100000">
+              <a:schemeClr val="phClr">
+                <a:shade val="63000"/>
+                <a:satMod val="120000"/>
+              </a:schemeClr>
+            </a:gs>
+          </a:gsLst>
+          <a:lin ang="5400000" scaled="0"/>
+        </a:gradFill>
+      </a:bgFillStyleLst>
+    </a:fmtScheme>
+  </a:themeElements>
+  <a:objectDefaults/>
+  <a:extraClrSchemeLst/>
+  <a:extLst>
+    <a:ext uri="{05A4C25C-085E-4340-85A3-A5531E510DB2}">
+      <thm15:themeFamily xmlns:thm15="http://schemas.microsoft.com/office/thememl/2012/main" name="Office Theme" id="{62F939B6-93AF-4DB8-9C6B-D6C7DFDC589F}" vid="{4A3C46E8-61CC-4603-A589-7422A47A8E4A}"/>
+    </a:ext>
+  </a:extLst>
+</a:theme>
 </file>
</xml_diff>